<commit_message>
Update project topic title to Sales Forecasting across all deliverables
</commit_message>
<xml_diff>
--- a/Walmart_Sales_Forecasting_Presentation.pptx
+++ b/Walmart_Sales_Forecasting_Presentation.pptx
@@ -4496,11 +4496,11 @@
               </a:defRPr>
             </a:pPr>
             <a:r>
-              <a:t>End-to-End Retail Store Sales Forecasting &amp;</a:t>
+              <a:t>Sales Forecasting:</a:t>
             </a:r>
             <a:br/>
             <a:r>
-              <a:t>Supply Chain Inventory Optimization</a:t>
+              <a:t>End-to-End Retail Store Sales &amp; Supply Chain Optimization</a:t>
             </a:r>
           </a:p>
           <a:p>
@@ -5197,7 +5197,7 @@
               </a:defRPr>
             </a:pPr>
             <a:r>
-              <a:t>Dev Dilip Dhapodkar (PRN: 24070521505)  |  Predictive Analytics CA3 — Walmart Store Sales Forecasting                                                           Slide 10 / 13</a:t>
+              <a:t>Dev Dilip Dhapodkar (PRN: 24070521505)  |  Predictive Analytics CA3 — Topic: Sales Forecasting                                                           Slide 10 / 13</a:t>
             </a:r>
           </a:p>
         </p:txBody>
@@ -5634,7 +5634,7 @@
               </a:defRPr>
             </a:pPr>
             <a:r>
-              <a:t>Dev Dilip Dhapodkar (PRN: 24070521505)  |  Predictive Analytics CA3 — Walmart Store Sales Forecasting                                                           Slide 11 / 13</a:t>
+              <a:t>Dev Dilip Dhapodkar (PRN: 24070521505)  |  Predictive Analytics CA3 — Topic: Sales Forecasting                                                           Slide 11 / 13</a:t>
             </a:r>
           </a:p>
         </p:txBody>
@@ -6087,7 +6087,7 @@
               </a:defRPr>
             </a:pPr>
             <a:r>
-              <a:t>Dev Dilip Dhapodkar (PRN: 24070521505)  |  Predictive Analytics CA3 — Walmart Store Sales Forecasting                                                           Slide 12 / 13</a:t>
+              <a:t>Dev Dilip Dhapodkar (PRN: 24070521505)  |  Predictive Analytics CA3 — Topic: Sales Forecasting                                                           Slide 12 / 13</a:t>
             </a:r>
           </a:p>
         </p:txBody>
@@ -6528,7 +6528,7 @@
               </a:defRPr>
             </a:pPr>
             <a:r>
-              <a:t>Dev Dilip Dhapodkar (PRN: 24070521505)  |  Predictive Analytics CA3 — Walmart Store Sales Forecasting                                                           Slide 13 / 13</a:t>
+              <a:t>Dev Dilip Dhapodkar (PRN: 24070521505)  |  Predictive Analytics CA3 — Topic: Sales Forecasting                                                           Slide 13 / 13</a:t>
             </a:r>
           </a:p>
         </p:txBody>
@@ -7367,7 +7367,7 @@
               </a:defRPr>
             </a:pPr>
             <a:r>
-              <a:t>Dev Dilip Dhapodkar (PRN: 24070521505)  |  Predictive Analytics CA3 — Walmart Store Sales Forecasting                                                           Slide 2 / 13</a:t>
+              <a:t>Dev Dilip Dhapodkar (PRN: 24070521505)  |  Predictive Analytics CA3 — Topic: Sales Forecasting                                                           Slide 2 / 13</a:t>
             </a:r>
           </a:p>
         </p:txBody>
@@ -8190,7 +8190,7 @@
               </a:defRPr>
             </a:pPr>
             <a:r>
-              <a:t>Dev Dilip Dhapodkar (PRN: 24070521505)  |  Predictive Analytics CA3 — Walmart Store Sales Forecasting                                                           Slide 3 / 13</a:t>
+              <a:t>Dev Dilip Dhapodkar (PRN: 24070521505)  |  Predictive Analytics CA3 — Topic: Sales Forecasting                                                           Slide 3 / 13</a:t>
             </a:r>
           </a:p>
         </p:txBody>
@@ -9401,7 +9401,7 @@
               </a:defRPr>
             </a:pPr>
             <a:r>
-              <a:t>Dev Dilip Dhapodkar (PRN: 24070521505)  |  Predictive Analytics CA3 — Walmart Store Sales Forecasting                                                           Slide 4 / 13</a:t>
+              <a:t>Dev Dilip Dhapodkar (PRN: 24070521505)  |  Predictive Analytics CA3 — Topic: Sales Forecasting                                                           Slide 4 / 13</a:t>
             </a:r>
           </a:p>
         </p:txBody>
@@ -10948,7 +10948,7 @@
               </a:defRPr>
             </a:pPr>
             <a:r>
-              <a:t>Dev Dilip Dhapodkar (PRN: 24070521505)  |  Predictive Analytics CA3 — Walmart Store Sales Forecasting                                                           Slide 5 / 13</a:t>
+              <a:t>Dev Dilip Dhapodkar (PRN: 24070521505)  |  Predictive Analytics CA3 — Topic: Sales Forecasting                                                           Slide 5 / 13</a:t>
             </a:r>
           </a:p>
         </p:txBody>
@@ -11722,7 +11722,7 @@
               </a:defRPr>
             </a:pPr>
             <a:r>
-              <a:t>Dev Dilip Dhapodkar (PRN: 24070521505)  |  Predictive Analytics CA3 — Walmart Store Sales Forecasting                                                           Slide 6 / 13</a:t>
+              <a:t>Dev Dilip Dhapodkar (PRN: 24070521505)  |  Predictive Analytics CA3 — Topic: Sales Forecasting                                                           Slide 6 / 13</a:t>
             </a:r>
           </a:p>
         </p:txBody>
@@ -12203,7 +12203,7 @@
               </a:defRPr>
             </a:pPr>
             <a:r>
-              <a:t>Dev Dilip Dhapodkar (PRN: 24070521505)  |  Predictive Analytics CA3 — Walmart Store Sales Forecasting                                                           Slide 7 / 13</a:t>
+              <a:t>Dev Dilip Dhapodkar (PRN: 24070521505)  |  Predictive Analytics CA3 — Topic: Sales Forecasting                                                           Slide 7 / 13</a:t>
             </a:r>
           </a:p>
         </p:txBody>
@@ -12680,7 +12680,7 @@
               </a:defRPr>
             </a:pPr>
             <a:r>
-              <a:t>Dev Dilip Dhapodkar (PRN: 24070521505)  |  Predictive Analytics CA3 — Walmart Store Sales Forecasting                                                           Slide 8 / 13</a:t>
+              <a:t>Dev Dilip Dhapodkar (PRN: 24070521505)  |  Predictive Analytics CA3 — Topic: Sales Forecasting                                                           Slide 8 / 13</a:t>
             </a:r>
           </a:p>
         </p:txBody>
@@ -13985,7 +13985,7 @@
               </a:defRPr>
             </a:pPr>
             <a:r>
-              <a:t>Dev Dilip Dhapodkar (PRN: 24070521505)  |  Predictive Analytics CA3 — Walmart Store Sales Forecasting                                                           Slide 9 / 13</a:t>
+              <a:t>Dev Dilip Dhapodkar (PRN: 24070521505)  |  Predictive Analytics CA3 — Topic: Sales Forecasting                                                           Slide 9 / 13</a:t>
             </a:r>
           </a:p>
         </p:txBody>

</xml_diff>

<commit_message>
Revert "Update project topic title to Sales Forecasting across all deliverables"
This reverts commit 6a981ba00a38b16362449658d53c4e9a16f6e399.
</commit_message>
<xml_diff>
--- a/Walmart_Sales_Forecasting_Presentation.pptx
+++ b/Walmart_Sales_Forecasting_Presentation.pptx
@@ -4496,11 +4496,11 @@
               </a:defRPr>
             </a:pPr>
             <a:r>
-              <a:t>Sales Forecasting:</a:t>
+              <a:t>End-to-End Retail Store Sales Forecasting &amp;</a:t>
             </a:r>
             <a:br/>
             <a:r>
-              <a:t>End-to-End Retail Store Sales &amp; Supply Chain Optimization</a:t>
+              <a:t>Supply Chain Inventory Optimization</a:t>
             </a:r>
           </a:p>
           <a:p>
@@ -5197,7 +5197,7 @@
               </a:defRPr>
             </a:pPr>
             <a:r>
-              <a:t>Dev Dilip Dhapodkar (PRN: 24070521505)  |  Predictive Analytics CA3 — Topic: Sales Forecasting                                                           Slide 10 / 13</a:t>
+              <a:t>Dev Dilip Dhapodkar (PRN: 24070521505)  |  Predictive Analytics CA3 — Walmart Store Sales Forecasting                                                           Slide 10 / 13</a:t>
             </a:r>
           </a:p>
         </p:txBody>
@@ -5634,7 +5634,7 @@
               </a:defRPr>
             </a:pPr>
             <a:r>
-              <a:t>Dev Dilip Dhapodkar (PRN: 24070521505)  |  Predictive Analytics CA3 — Topic: Sales Forecasting                                                           Slide 11 / 13</a:t>
+              <a:t>Dev Dilip Dhapodkar (PRN: 24070521505)  |  Predictive Analytics CA3 — Walmart Store Sales Forecasting                                                           Slide 11 / 13</a:t>
             </a:r>
           </a:p>
         </p:txBody>
@@ -6087,7 +6087,7 @@
               </a:defRPr>
             </a:pPr>
             <a:r>
-              <a:t>Dev Dilip Dhapodkar (PRN: 24070521505)  |  Predictive Analytics CA3 — Topic: Sales Forecasting                                                           Slide 12 / 13</a:t>
+              <a:t>Dev Dilip Dhapodkar (PRN: 24070521505)  |  Predictive Analytics CA3 — Walmart Store Sales Forecasting                                                           Slide 12 / 13</a:t>
             </a:r>
           </a:p>
         </p:txBody>
@@ -6528,7 +6528,7 @@
               </a:defRPr>
             </a:pPr>
             <a:r>
-              <a:t>Dev Dilip Dhapodkar (PRN: 24070521505)  |  Predictive Analytics CA3 — Topic: Sales Forecasting                                                           Slide 13 / 13</a:t>
+              <a:t>Dev Dilip Dhapodkar (PRN: 24070521505)  |  Predictive Analytics CA3 — Walmart Store Sales Forecasting                                                           Slide 13 / 13</a:t>
             </a:r>
           </a:p>
         </p:txBody>
@@ -7367,7 +7367,7 @@
               </a:defRPr>
             </a:pPr>
             <a:r>
-              <a:t>Dev Dilip Dhapodkar (PRN: 24070521505)  |  Predictive Analytics CA3 — Topic: Sales Forecasting                                                           Slide 2 / 13</a:t>
+              <a:t>Dev Dilip Dhapodkar (PRN: 24070521505)  |  Predictive Analytics CA3 — Walmart Store Sales Forecasting                                                           Slide 2 / 13</a:t>
             </a:r>
           </a:p>
         </p:txBody>
@@ -8190,7 +8190,7 @@
               </a:defRPr>
             </a:pPr>
             <a:r>
-              <a:t>Dev Dilip Dhapodkar (PRN: 24070521505)  |  Predictive Analytics CA3 — Topic: Sales Forecasting                                                           Slide 3 / 13</a:t>
+              <a:t>Dev Dilip Dhapodkar (PRN: 24070521505)  |  Predictive Analytics CA3 — Walmart Store Sales Forecasting                                                           Slide 3 / 13</a:t>
             </a:r>
           </a:p>
         </p:txBody>
@@ -9401,7 +9401,7 @@
               </a:defRPr>
             </a:pPr>
             <a:r>
-              <a:t>Dev Dilip Dhapodkar (PRN: 24070521505)  |  Predictive Analytics CA3 — Topic: Sales Forecasting                                                           Slide 4 / 13</a:t>
+              <a:t>Dev Dilip Dhapodkar (PRN: 24070521505)  |  Predictive Analytics CA3 — Walmart Store Sales Forecasting                                                           Slide 4 / 13</a:t>
             </a:r>
           </a:p>
         </p:txBody>
@@ -10948,7 +10948,7 @@
               </a:defRPr>
             </a:pPr>
             <a:r>
-              <a:t>Dev Dilip Dhapodkar (PRN: 24070521505)  |  Predictive Analytics CA3 — Topic: Sales Forecasting                                                           Slide 5 / 13</a:t>
+              <a:t>Dev Dilip Dhapodkar (PRN: 24070521505)  |  Predictive Analytics CA3 — Walmart Store Sales Forecasting                                                           Slide 5 / 13</a:t>
             </a:r>
           </a:p>
         </p:txBody>
@@ -11722,7 +11722,7 @@
               </a:defRPr>
             </a:pPr>
             <a:r>
-              <a:t>Dev Dilip Dhapodkar (PRN: 24070521505)  |  Predictive Analytics CA3 — Topic: Sales Forecasting                                                           Slide 6 / 13</a:t>
+              <a:t>Dev Dilip Dhapodkar (PRN: 24070521505)  |  Predictive Analytics CA3 — Walmart Store Sales Forecasting                                                           Slide 6 / 13</a:t>
             </a:r>
           </a:p>
         </p:txBody>
@@ -12203,7 +12203,7 @@
               </a:defRPr>
             </a:pPr>
             <a:r>
-              <a:t>Dev Dilip Dhapodkar (PRN: 24070521505)  |  Predictive Analytics CA3 — Topic: Sales Forecasting                                                           Slide 7 / 13</a:t>
+              <a:t>Dev Dilip Dhapodkar (PRN: 24070521505)  |  Predictive Analytics CA3 — Walmart Store Sales Forecasting                                                           Slide 7 / 13</a:t>
             </a:r>
           </a:p>
         </p:txBody>
@@ -12680,7 +12680,7 @@
               </a:defRPr>
             </a:pPr>
             <a:r>
-              <a:t>Dev Dilip Dhapodkar (PRN: 24070521505)  |  Predictive Analytics CA3 — Topic: Sales Forecasting                                                           Slide 8 / 13</a:t>
+              <a:t>Dev Dilip Dhapodkar (PRN: 24070521505)  |  Predictive Analytics CA3 — Walmart Store Sales Forecasting                                                           Slide 8 / 13</a:t>
             </a:r>
           </a:p>
         </p:txBody>
@@ -13985,7 +13985,7 @@
               </a:defRPr>
             </a:pPr>
             <a:r>
-              <a:t>Dev Dilip Dhapodkar (PRN: 24070521505)  |  Predictive Analytics CA3 — Topic: Sales Forecasting                                                           Slide 9 / 13</a:t>
+              <a:t>Dev Dilip Dhapodkar (PRN: 24070521505)  |  Predictive Analytics CA3 — Walmart Store Sales Forecasting                                                           Slide 9 / 13</a:t>
             </a:r>
           </a:p>
         </p:txBody>

</xml_diff>

<commit_message>
Simplify presentation deck: single-focus bold charts, minimal text cards, and timed 6-min speaker notes
</commit_message>
<xml_diff>
--- a/Walmart_Sales_Forecasting_Presentation.pptx
+++ b/Walmart_Sales_Forecasting_Presentation.pptx
@@ -508,7 +508,7 @@
           <a:lstStyle/>
           <a:p>
             <a:r>
-              <a:t>[Target Time: 0:00 - 0:40]</a:t>
+              <a:t>[Time: 0:00 - 0:35]</a:t>
             </a:r>
           </a:p>
           <a:p>
@@ -518,19 +518,13 @@
           </a:p>
           <a:p>
             <a:r>
-              <a:t>"Good morning everyone and respected professor. My name is Dev Dilip Dhapodkar, PRN 24070521505. Today I am presenting my Predictive Analytics CA3 project on 'Sales Forecasting'.</a:t>
+              <a:t>"Good morning, Professor. My name is Dev Dilip Dhapodkar, PRN 24070521505. Today, I am presenting my Predictive Analytics CA3 project on 'Sales Forecasting'.</a:t>
             </a:r>
           </a:p>
           <a:p/>
           <a:p>
             <a:r>
-              <a:t>In this project, I developed an end-to-end predictive machine learning model to forecast weekly department-level sales across 45 Walmart stores using historical sales, promotional markdowns, holiday calendar events, and macroeconomic indicators. </a:t>
-            </a:r>
-          </a:p>
-          <a:p/>
-          <a:p>
-            <a:r>
-              <a:t>Following the Knowledge Discovery in Databases (KDD) process, my final model achieved a 60% reduction in Weighted Mean Absolute Error and an R² of 0.9725. Let me walk you through the problem, the workflow, the models, and the key results."</a:t>
+              <a:t>Using the official Kaggle Walmart dataset of over 421,000 records across 45 stores, I developed an end-to-end machine learning pipeline that forecasts weekly sales, reduces forecast error by 60%, and achieves an R² of 0.9725 to optimize retail supply chain inventory."</a:t>
             </a:r>
           </a:p>
           <a:p/>
@@ -601,7 +595,7 @@
           <a:lstStyle/>
           <a:p>
             <a:r>
-              <a:t>[Target Time: 0:40 - 1:30]</a:t>
+              <a:t>[Time: 0:35 - 1:25]</a:t>
             </a:r>
           </a:p>
           <a:p>
@@ -611,13 +605,28 @@
           </a:p>
           <a:p>
             <a:r>
-              <a:t>"In retail supply chains, forecast errors are asymmetric. If you under-forecast during a holiday like Thanksgiving, you face stockouts and lost revenue. If you over-forecast, you get hit with holding costs and clearance losses. That is why the evaluation metric for this competition—Weighted Mean Absolute Error (WMAE)—assigns five times more weight to holiday weeks.</a:t>
+              <a:t>"Looking at Slide 2: Figure 1 plots total weekly sales across all 45 Walmart stores over nearly three years. </a:t>
+            </a:r>
+          </a:p>
+          <a:p>
+            <a:r>
+              <a:t>Notice the two massive red and orange spikes every November and December:</a:t>
+            </a:r>
+          </a:p>
+          <a:p>
+            <a:r>
+              <a:t>- On Thanksgiving and Black Friday, weekly sales surge by +44% to over $66 million.</a:t>
+            </a:r>
+          </a:p>
+          <a:p>
+            <a:r>
+              <a:t>- During the pre-Christmas rush, sales spike by +40% to over $80 million, followed by an immediate collapse once stores close.</a:t>
             </a:r>
           </a:p>
           <a:p/>
           <a:p>
             <a:r>
-              <a:t>To solve this, I structured the project around the systematic KDD process across seven stages: from ingesting 421,000 records, to cleaning markdowns and negative returns, engineering 43 leak-free predictive features, and benchmarking four distinct machine learning algorithms."</a:t>
+              <a:t>For supply chain managers, under-forecasting during holidays causes severe out-of-stock penalties. That is why our competition metric—Weighted Mean Absolute Error (WMAE)—weights holiday errors five times heavier than normal weeks."</a:t>
             </a:r>
           </a:p>
           <a:p/>
@@ -688,7 +697,7 @@
           <a:lstStyle/>
           <a:p>
             <a:r>
-              <a:t>[Target Time: 1:30 - 2:20]</a:t>
+              <a:t>[Time: 1:25 - 2:15]</a:t>
             </a:r>
           </a:p>
           <a:p>
@@ -698,18 +707,18 @@
           </a:p>
           <a:p>
             <a:r>
-              <a:t>"Moving to Data Preprocessing. We faced two major data challenges shown in Figure 2:</a:t>
-            </a:r>
-          </a:p>
-          <a:p>
-            <a:r>
-              <a:t>First, promotional markdowns (MarkDown1 through 5) had 64% to 74% missing values. This wasn't random missing data—Walmart only introduced tracking in late 2011, and markdowns only occur during promotions. Before imputing with zero, we created indicator features like 'Has_MarkDown' and 'Active_MarkDown_Count' so the model knows when a promotion was active.</a:t>
+              <a:t>"Next, in Data Preprocessing, we tackled two critical real-world issues shown on the chart:</a:t>
+            </a:r>
+          </a:p>
+          <a:p>
+            <a:r>
+              <a:t>First, promotional markdowns (MarkDown1 through 5) had 64% to 74% missing values. This is because markdowns were only introduced in late 2011. Instead of naive imputation, we created an active promotional flag and then imputed zeros, giving the model clear promo signals.</a:t>
             </a:r>
           </a:p>
           <a:p/>
           <a:p>
             <a:r>
-              <a:t>Second, 1,285 records had negative sales due to customer returns, which we floored at zero. For outliers, we carefully distinguished between anomalous errors and real holiday spikes. We capped non-holiday outliers at the 99.95th percentile while preserving authentic holiday sales peaks."</a:t>
+              <a:t>Second, 1,285 records showed negative sales due to customer returns, which we floored at zero. For outliers, we carefully winsorized only non-holiday anomalies at the 99.95th percentile, ensuring real holiday demand surges were never accidentally erased."</a:t>
             </a:r>
           </a:p>
           <a:p/>
@@ -780,7 +789,7 @@
           <a:lstStyle/>
           <a:p>
             <a:r>
-              <a:t>[Target Time: 2:20 - 3:10]</a:t>
+              <a:t>[Time: 2:15 - 3:05]</a:t>
             </a:r>
           </a:p>
           <a:p>
@@ -790,33 +799,28 @@
           </a:p>
           <a:p>
             <a:r>
-              <a:t>"In Step 3, feature engineering is where predictive power is won or lost. We engineered 43 domain-specific features across four categories:</a:t>
-            </a:r>
-          </a:p>
-          <a:p>
-            <a:r>
-              <a:t>1. Autoregressive lags: Lag 1, 2, 4, and most importantly Lag 52, which captures exact year-over-year seasonality.</a:t>
-            </a:r>
-          </a:p>
-          <a:p>
-            <a:r>
-              <a:t>2. Leak-free rolling statistics: 4-week and 12-week moving averages, strictly shifted by one week so no future data leaks into the model.</a:t>
-            </a:r>
-          </a:p>
-          <a:p>
-            <a:r>
-              <a:t>3. Explicit holiday flags: Not just a generic 'is holiday' flag, but specific indicators for Thanksgiving (which delivers a +44% revenue surge), Pre-Christmas peak, Super Bowl, and Labor Day.</a:t>
-            </a:r>
-          </a:p>
-          <a:p>
-            <a:r>
-              <a:t>4. Cyclical Fourier sine and cosine features to handle circular calendar seasonality.</a:t>
+              <a:t>"In Step 3, we engineered 43 domain-specific features. As the chart on the left illustrates:</a:t>
+            </a:r>
+          </a:p>
+          <a:p>
+            <a:r>
+              <a:t>1. The single most powerful feature is 'Lag 52'—sales from the exact same week one year ago—which accounts for 41% of total model gain! Retail demand is intensely seasonal, so last year's sales provide the baseline.</a:t>
+            </a:r>
+          </a:p>
+          <a:p>
+            <a:r>
+              <a:t>2. The next 40% of gain comes from short-term momentum: prior week sales (Lag 1) and the recent 4-week moving average.</a:t>
+            </a:r>
+          </a:p>
+          <a:p>
+            <a:r>
+              <a:t>3. Specific holiday flags like Thanksgiving provide the final non-linear boost during Q4.</a:t>
             </a:r>
           </a:p>
           <a:p/>
           <a:p>
             <a:r>
-              <a:t>As shown in the correlation matrix on the left, Lag 52 (r = 0.97) and Rolling Mean 4 (r = 0.96) show the highest correlation with sales."</a:t>
+              <a:t>Crucially, all rolling averages were strictly shifted by one week to eliminate any look-ahead bias or data leakage."</a:t>
             </a:r>
           </a:p>
           <a:p/>
@@ -887,7 +891,7 @@
           <a:lstStyle/>
           <a:p>
             <a:r>
-              <a:t>[Target Time: 3:10 - 4:15]</a:t>
+              <a:t>[Time: 3:05 - 4:00]</a:t>
             </a:r>
           </a:p>
           <a:p>
@@ -897,54 +901,38 @@
           </a:p>
           <a:p>
             <a:r>
-              <a:t>"Now looking at Model Training and Evaluation. We partitioned the data chronologically at November 25, 2011. This gave us 263,000 training records and an out-of-sample validation set of 145,000 records spanning 49 weeks and covering all four major holidays.</a:t>
+              <a:t>"Now looking at Model Benchmarking on Slide 5. We evaluated four algorithms on an unseen 49-week validation horizon containing 145,000 department-week records.</a:t>
             </a:r>
           </a:p>
           <a:p/>
           <a:p>
             <a:r>
-              <a:t>We trained four models with sample weights of w = 5 on holiday weeks:</a:t>
-            </a:r>
-          </a:p>
-          <a:p>
-            <a:r>
-              <a:t>1. Baseline Ridge Regression</a:t>
-            </a:r>
-          </a:p>
-          <a:p>
-            <a:r>
-              <a:t>2. Random Forest Regressor</a:t>
-            </a:r>
-          </a:p>
-          <a:p>
-            <a:r>
-              <a:t>3. XGBoost Regressor</a:t>
-            </a:r>
-          </a:p>
-          <a:p>
-            <a:r>
-              <a:t>4. LightGBM Regressor</a:t>
-            </a:r>
-          </a:p>
-          <a:p/>
-          <a:p>
-            <a:r>
-              <a:t>Here are the key takeaways:</a:t>
-            </a:r>
-          </a:p>
-          <a:p>
-            <a:r>
-              <a:t>- LightGBM was the clear winner: It achieved the lowest WMAE of $1,758.94—a 60% error reduction over the baseline—the lowest RMSE of $3,837, and the highest R² of 0.9725, training in just 4.9 seconds!</a:t>
-            </a:r>
-          </a:p>
-          <a:p>
-            <a:r>
-              <a:t>- Look at the Holiday MAE column: Ridge regression failed completely during holidays, with an error of over $10,000 per department-week. LightGBM cut holiday error by 76% down to $2,421.</a:t>
-            </a:r>
-          </a:p>
-          <a:p>
-            <a:r>
-              <a:t>- For regular non-holiday weeks, XGBoost was slightly better at $1,410 MAE, making both gradient-boosted models exceptionally strong."</a:t>
+              <a:t>As the bar chart shows:</a:t>
+            </a:r>
+          </a:p>
+          <a:p>
+            <a:r>
+              <a:t>- The linear Baseline Ridge model struggled, with a WMAE of $4,393 and a catastrophic holiday error of over $10,000 per department. Linear models simply cannot handle non-linear holiday spikes.</a:t>
+            </a:r>
+          </a:p>
+          <a:p>
+            <a:r>
+              <a:t>- Tree ensembles dramatically improved accuracy:</a:t>
+            </a:r>
+          </a:p>
+          <a:p>
+            <a:r>
+              <a:t>- Random Forest achieved $1,792.</a:t>
+            </a:r>
+          </a:p>
+          <a:p>
+            <a:r>
+              <a:t>- XGBoost achieved $1,838.</a:t>
+            </a:r>
+          </a:p>
+          <a:p>
+            <a:r>
+              <a:t>- LightGBM was the overall winner, achieving the lowest WMAE of $1,759—a 60% error reduction—and an R² of 0.9725, while training in under 5 seconds!"</a:t>
             </a:r>
           </a:p>
           <a:p/>
@@ -1015,7 +1003,7 @@
           <a:lstStyle/>
           <a:p>
             <a:r>
-              <a:t>[Target Time: 4:15 - 5:00]</a:t>
+              <a:t>[Time: 4:00 - 4:50]</a:t>
             </a:r>
           </a:p>
           <a:p>
@@ -1025,23 +1013,18 @@
           </a:p>
           <a:p>
             <a:r>
-              <a:t>"Figure 6 provides visual confirmation of our validation results.</a:t>
-            </a:r>
-          </a:p>
-          <a:p>
-            <a:r>
-              <a:t>In Panel A on the left, the black line represents actual aggregate weekly sales across the 49-week validation horizon. The yellow circles mark holiday weeks. </a:t>
-            </a:r>
-          </a:p>
-          <a:p>
-            <a:r>
-              <a:t>Notice how the grey dotted line—the linear baseline—completely overshoots immediately after Thanksgiving and Christmas. In contrast, LightGBM (blue) and XGBoost (red) track the peaks and post-holiday dips with high precision.</a:t>
+              <a:t>"Slide 6 shows the actual proof of model performance:</a:t>
+            </a:r>
+          </a:p>
+          <a:p>
+            <a:r>
+              <a:t>The black solid line is actual weekly sales across the 45 stores; the dashed green line is our LightGBM forecast.</a:t>
             </a:r>
           </a:p>
           <a:p/>
           <a:p>
             <a:r>
-              <a:t>In Panel B on the right, you can see the predicted vs actual scatter plot on 8,000 sampled validation points. The points align tightly along the red 45-degree parity line, confirming consistent accuracy across both low-volume and high-volume departments."</a:t>
+              <a:t>Notice how the green forecast hugs the black line through every seasonal dip and rises smoothly to capture the massive 77-million-dollar holiday peak. More importantly, it immediately adjusts downwards right after the holidays, preventing overstocking in January."</a:t>
             </a:r>
           </a:p>
           <a:p/>
@@ -1112,7 +1095,7 @@
           <a:lstStyle/>
           <a:p>
             <a:r>
-              <a:t>[Target Time: 5:00 - 6:00]</a:t>
+              <a:t>[Time: 4:50 - 5:45]</a:t>
             </a:r>
           </a:p>
           <a:p>
@@ -1122,34 +1105,39 @@
           </a:p>
           <a:p>
             <a:r>
-              <a:t>"Finally, let's connect model accuracy to business impact:</a:t>
-            </a:r>
-          </a:p>
-          <a:p>
-            <a:r>
-              <a:t>1. Feature Importance: The single most important feature was Lag 52 (sales from the same week last year), accounting for 41% of LightGBM's gain. Short-term rolling means and explicit holiday flags accounted for the rest.</a:t>
-            </a:r>
-          </a:p>
-          <a:p>
-            <a:r>
-              <a:t>2. Supply Chain Impact: As shown in Figure 8 Panel B, applying a standard 22% inventory holding and stockout penalty factor across the 49-week horizon, moving from the baseline to gradient boosting reduces inventory mismatch costs from $80.3M down to $48.6M. That is an estimated savings of $31.7 million dollars—or a 39.5% cost reduction across all 45 stores.</a:t>
+              <a:t>"Finally, on Slide 7, we translate statistical accuracy into business dollars:</a:t>
+            </a:r>
+          </a:p>
+          <a:p>
+            <a:r>
+              <a:t>In retail supply chain management, forecast errors mean paying for excess safety stock or losing margins due to empty shelves. Applying an industry-standard 22% penalty factor:</a:t>
+            </a:r>
+          </a:p>
+          <a:p>
+            <a:r>
+              <a:t>- Total inventory mismatch cost is slashed from $80.3 million down to $48.6 million.</a:t>
+            </a:r>
+          </a:p>
+          <a:p>
+            <a:r>
+              <a:t>- That is a direct savings of $31.7 million—or 39%—across all 45 Walmart stores ($17M saved in Supercenters and $13M in Discount stores).</a:t>
             </a:r>
           </a:p>
           <a:p/>
           <a:p>
             <a:r>
-              <a:t>To conclude:</a:t>
-            </a:r>
-          </a:p>
-          <a:p>
-            <a:r>
-              <a:t>We implemented an end-to-end KDD pipeline for Sales Forecasting. Our gradient-boosted models cut WMAE by 60% and explained 97.25% of sales variance. For deployment, we recommend LightGBM for high-stakes holiday pre-staging and XGBoost for routine weekly automated replenishment.</a:t>
+              <a:t>In conclusion:</a:t>
+            </a:r>
+          </a:p>
+          <a:p>
+            <a:r>
+              <a:t>Following the KDD process, we engineered 43 features and built a LightGBM model that cuts error by 60%, explains 97.25% of sales variance, and protects holiday revenue.</a:t>
             </a:r>
           </a:p>
           <a:p/>
           <a:p>
             <a:r>
-              <a:t>Thank you for your time, and I am happy to answer any questions."</a:t>
+              <a:t>Thank you very much. I am now open to your questions."</a:t>
             </a:r>
           </a:p>
           <a:p/>
@@ -4208,7 +4196,7 @@
         <p:spPr>
           <a:xfrm>
             <a:off x="0" y="0"/>
-            <a:ext cx="320040" cy="6858000"/>
+            <a:ext cx="365760" cy="6858000"/>
           </a:xfrm>
           <a:prstGeom prst="rect">
             <a:avLst/>
@@ -4250,8 +4238,8 @@
         </p:nvSpPr>
         <p:spPr>
           <a:xfrm>
-            <a:off x="914400" y="1005840"/>
-            <a:ext cx="10515600" cy="2926080"/>
+            <a:off x="1005840" y="1005840"/>
+            <a:ext cx="10241280" cy="3108960"/>
           </a:xfrm>
           <a:prstGeom prst="rect">
             <a:avLst/>
@@ -4266,9 +4254,9 @@
           <a:p>
             <a:pPr>
               <a:spcAft>
-                <a:spcPts val="1000"/>
+                <a:spcPts val="1200"/>
               </a:spcAft>
-              <a:defRPr sz="1400" b="1">
+              <a:defRPr sz="1500" b="1">
                 <a:solidFill>
                   <a:srgbClr val="FFC220"/>
                 </a:solidFill>
@@ -4276,15 +4264,15 @@
               </a:defRPr>
             </a:pPr>
             <a:r>
-              <a:t>PREDICTIVE ANALYTICS — CA3 PROJECT PRESENTATION</a:t>
+              <a:t>PREDICTIVE ANALYTICS — CA3 PRESENTATION</a:t>
             </a:r>
           </a:p>
           <a:p>
             <a:pPr>
               <a:spcAft>
-                <a:spcPts val="600"/>
+                <a:spcPts val="800"/>
               </a:spcAft>
-              <a:defRPr sz="4000" b="1">
+              <a:defRPr sz="4400" b="1">
                 <a:solidFill>
                   <a:srgbClr val="FFFFFF"/>
                 </a:solidFill>
@@ -4298,9 +4286,9 @@
           <a:p>
             <a:pPr>
               <a:spcAft>
-                <a:spcPts val="1800"/>
+                <a:spcPts val="2000"/>
               </a:spcAft>
-              <a:defRPr sz="1800">
+              <a:defRPr sz="1900">
                 <a:solidFill>
                   <a:srgbClr val="BAE6FD"/>
                 </a:solidFill>
@@ -4313,7 +4301,7 @@
           </a:p>
           <a:p>
             <a:pPr>
-              <a:defRPr sz="1600" b="1">
+              <a:defRPr sz="1700" b="1">
                 <a:solidFill>
                   <a:srgbClr val="FFC220"/>
                 </a:solidFill>
@@ -4334,8 +4322,8 @@
         </p:nvSpPr>
         <p:spPr>
           <a:xfrm>
-            <a:off x="914400" y="4389120"/>
-            <a:ext cx="3108960" cy="1371600"/>
+            <a:off x="1005840" y="4434840"/>
+            <a:ext cx="3108960" cy="1463040"/>
           </a:xfrm>
           <a:prstGeom prst="roundRect">
             <a:avLst>
@@ -4379,8 +4367,8 @@
         </p:nvSpPr>
         <p:spPr>
           <a:xfrm>
-            <a:off x="914400" y="4526280"/>
-            <a:ext cx="3108960" cy="1097280"/>
+            <a:off x="1005840" y="4572000"/>
+            <a:ext cx="3108960" cy="1188720"/>
           </a:xfrm>
           <a:prstGeom prst="rect">
             <a:avLst/>
@@ -4394,7 +4382,7 @@
           <a:lstStyle/>
           <a:p>
             <a:pPr algn="ctr">
-              <a:defRPr sz="2400" b="1">
+              <a:defRPr sz="2600" b="1">
                 <a:solidFill>
                   <a:srgbClr val="0071CE"/>
                 </a:solidFill>
@@ -4407,7 +4395,7 @@
           </a:p>
           <a:p>
             <a:pPr algn="ctr">
-              <a:defRPr sz="1100" b="1">
+              <a:defRPr sz="1200" b="1">
                 <a:solidFill>
                   <a:srgbClr val="0F2942"/>
                 </a:solidFill>
@@ -4415,12 +4403,12 @@
               </a:defRPr>
             </a:pPr>
             <a:r>
-              <a:t>Historical Sales Records</a:t>
+              <a:t>Walmart Sales Records</a:t>
             </a:r>
           </a:p>
           <a:p>
             <a:pPr algn="ctr">
-              <a:defRPr sz="950">
+              <a:defRPr sz="1000">
                 <a:solidFill>
                   <a:srgbClr val="64748B"/>
                 </a:solidFill>
@@ -4428,7 +4416,7 @@
               </a:defRPr>
             </a:pPr>
             <a:r>
-              <a:t>45 Stores × 81 Depts (143 Weeks)</a:t>
+              <a:t>45 Stores × 81 Departments</a:t>
             </a:r>
           </a:p>
         </p:txBody>
@@ -4441,8 +4429,8 @@
         </p:nvSpPr>
         <p:spPr>
           <a:xfrm>
-            <a:off x="4480560" y="4389120"/>
-            <a:ext cx="3108960" cy="1371600"/>
+            <a:off x="4572000" y="4434840"/>
+            <a:ext cx="3108960" cy="1463040"/>
           </a:xfrm>
           <a:prstGeom prst="roundRect">
             <a:avLst>
@@ -4486,8 +4474,8 @@
         </p:nvSpPr>
         <p:spPr>
           <a:xfrm>
-            <a:off x="4480560" y="4526280"/>
-            <a:ext cx="3108960" cy="1097280"/>
+            <a:off x="4572000" y="4572000"/>
+            <a:ext cx="3108960" cy="1188720"/>
           </a:xfrm>
           <a:prstGeom prst="rect">
             <a:avLst/>
@@ -4501,7 +4489,7 @@
           <a:lstStyle/>
           <a:p>
             <a:pPr algn="ctr">
-              <a:defRPr sz="2400" b="1">
+              <a:defRPr sz="2600" b="1">
                 <a:solidFill>
                   <a:srgbClr val="0071CE"/>
                 </a:solidFill>
@@ -4509,12 +4497,12 @@
               </a:defRPr>
             </a:pPr>
             <a:r>
-              <a:t>60.0%</a:t>
+              <a:t>-60.0%</a:t>
             </a:r>
           </a:p>
           <a:p>
             <a:pPr algn="ctr">
-              <a:defRPr sz="1100" b="1">
+              <a:defRPr sz="1200" b="1">
                 <a:solidFill>
                   <a:srgbClr val="0F2942"/>
                 </a:solidFill>
@@ -4527,7 +4515,7 @@
           </a:p>
           <a:p>
             <a:pPr algn="ctr">
-              <a:defRPr sz="950">
+              <a:defRPr sz="1000">
                 <a:solidFill>
                   <a:srgbClr val="64748B"/>
                 </a:solidFill>
@@ -4535,7 +4523,7 @@
               </a:defRPr>
             </a:pPr>
             <a:r>
-              <a:t>$1,758.94 vs $4,393 Baseline</a:t>
+              <a:t>$1,759 vs $4,393 Baseline</a:t>
             </a:r>
           </a:p>
         </p:txBody>
@@ -4548,8 +4536,8 @@
         </p:nvSpPr>
         <p:spPr>
           <a:xfrm>
-            <a:off x="8046720" y="4389120"/>
-            <a:ext cx="3108960" cy="1371600"/>
+            <a:off x="8138160" y="4434840"/>
+            <a:ext cx="3108960" cy="1463040"/>
           </a:xfrm>
           <a:prstGeom prst="roundRect">
             <a:avLst>
@@ -4593,8 +4581,8 @@
         </p:nvSpPr>
         <p:spPr>
           <a:xfrm>
-            <a:off x="8046720" y="4526280"/>
-            <a:ext cx="3108960" cy="1097280"/>
+            <a:off x="8138160" y="4572000"/>
+            <a:ext cx="3108960" cy="1188720"/>
           </a:xfrm>
           <a:prstGeom prst="rect">
             <a:avLst/>
@@ -4608,7 +4596,7 @@
           <a:lstStyle/>
           <a:p>
             <a:pPr algn="ctr">
-              <a:defRPr sz="2400" b="1">
+              <a:defRPr sz="2600" b="1">
                 <a:solidFill>
                   <a:srgbClr val="0071CE"/>
                 </a:solidFill>
@@ -4616,12 +4604,12 @@
               </a:defRPr>
             </a:pPr>
             <a:r>
-              <a:t>0.9725</a:t>
+              <a:t>R² = 0.9725</a:t>
             </a:r>
           </a:p>
           <a:p>
             <a:pPr algn="ctr">
-              <a:defRPr sz="1100" b="1">
+              <a:defRPr sz="1200" b="1">
                 <a:solidFill>
                   <a:srgbClr val="0F2942"/>
                 </a:solidFill>
@@ -4629,12 +4617,12 @@
               </a:defRPr>
             </a:pPr>
             <a:r>
-              <a:t>Coefficient of Determination</a:t>
+              <a:t>Variance Explained</a:t>
             </a:r>
           </a:p>
           <a:p>
             <a:pPr algn="ctr">
-              <a:defRPr sz="950">
+              <a:defRPr sz="1000">
                 <a:solidFill>
                   <a:srgbClr val="64748B"/>
                 </a:solidFill>
@@ -4642,7 +4630,7 @@
               </a:defRPr>
             </a:pPr>
             <a:r>
-              <a:t>R² Score on Unseen 49-Week Test</a:t>
+              <a:t>$31.7M Supply Chain Savings</a:t>
             </a:r>
           </a:p>
         </p:txBody>
@@ -4717,7 +4705,7 @@
         <p:spPr>
           <a:xfrm>
             <a:off x="0" y="0"/>
-            <a:ext cx="12191695" cy="914400"/>
+            <a:ext cx="12191695" cy="960120"/>
           </a:xfrm>
           <a:prstGeom prst="rect">
             <a:avLst/>
@@ -4759,8 +4747,8 @@
         </p:nvSpPr>
         <p:spPr>
           <a:xfrm>
-            <a:off x="0" y="914400"/>
-            <a:ext cx="12191695" cy="45720"/>
+            <a:off x="0" y="960120"/>
+            <a:ext cx="12191695" cy="54864"/>
           </a:xfrm>
           <a:prstGeom prst="rect">
             <a:avLst/>
@@ -4802,8 +4790,8 @@
         </p:nvSpPr>
         <p:spPr>
           <a:xfrm>
-            <a:off x="548640" y="91440"/>
-            <a:ext cx="9601200" cy="777240"/>
+            <a:off x="594360" y="109728"/>
+            <a:ext cx="10058400" cy="777240"/>
           </a:xfrm>
           <a:prstGeom prst="rect">
             <a:avLst/>
@@ -4817,7 +4805,7 @@
           <a:lstStyle/>
           <a:p>
             <a:pPr>
-              <a:defRPr sz="2200" b="1">
+              <a:defRPr sz="2300" b="1">
                 <a:solidFill>
                   <a:srgbClr val="FFFFFF"/>
                 </a:solidFill>
@@ -4825,12 +4813,12 @@
               </a:defRPr>
             </a:pPr>
             <a:r>
-              <a:t>1. Problem Statement &amp; KDD Workflow</a:t>
+              <a:t>1. The Challenge: Massive Recurring Holiday Surges</a:t>
             </a:r>
           </a:p>
           <a:p>
             <a:pPr>
-              <a:defRPr sz="1150">
+              <a:defRPr sz="1200">
                 <a:solidFill>
                   <a:srgbClr val="BAE6FD"/>
                 </a:solidFill>
@@ -4838,7 +4826,7 @@
               </a:defRPr>
             </a:pPr>
             <a:r>
-              <a:t>Addressing Asymmetric Supply Chain Costs Through Systematic Data Mining</a:t>
+              <a:t>Why Retail Forecasting Is Critical for Supply Chain Inventory Planning</a:t>
             </a:r>
           </a:p>
         </p:txBody>
@@ -4851,8 +4839,8 @@
         </p:nvSpPr>
         <p:spPr>
           <a:xfrm>
-            <a:off x="548640" y="6510528"/>
-            <a:ext cx="11094415" cy="274320"/>
+            <a:off x="594360" y="6510528"/>
+            <a:ext cx="10972800" cy="274320"/>
           </a:xfrm>
           <a:prstGeom prst="rect">
             <a:avLst/>
@@ -4879,20 +4867,44 @@
           </a:p>
         </p:txBody>
       </p:sp>
-      <p:sp>
-        <p:nvSpPr>
-          <p:cNvPr id="7" name="Rounded Rectangle 6"/>
+      <p:pic>
+        <p:nvPicPr>
+          <p:cNvPr id="7" name="Picture 6" descr="chart1_sales_spikes.png"/>
+          <p:cNvPicPr>
+            <a:picLocks noChangeAspect="1"/>
+          </p:cNvPicPr>
+          <p:nvPr/>
+        </p:nvPicPr>
+        <p:blipFill>
+          <a:blip r:embed="rId2"/>
+          <a:stretch>
+            <a:fillRect/>
+          </a:stretch>
+        </p:blipFill>
+        <p:spPr>
+          <a:xfrm>
+            <a:off x="594360" y="1234440"/>
+            <a:ext cx="7132320" cy="4027663"/>
+          </a:xfrm>
+          <a:prstGeom prst="rect">
+            <a:avLst/>
+          </a:prstGeom>
+        </p:spPr>
+      </p:pic>
+      <p:sp>
+        <p:nvSpPr>
+          <p:cNvPr id="8" name="Rounded Rectangle 7"/>
           <p:cNvSpPr/>
           <p:nvPr/>
         </p:nvSpPr>
         <p:spPr>
           <a:xfrm>
-            <a:off x="548640" y="1143000"/>
-            <a:ext cx="4023360" cy="2468880"/>
+            <a:off x="7955279" y="1234440"/>
+            <a:ext cx="3657600" cy="2468880"/>
           </a:xfrm>
           <a:prstGeom prst="roundRect">
             <a:avLst>
-              <a:gd name="adj" fmla="val 3000"/>
+              <a:gd name="adj" fmla="val 4000"/>
             </a:avLst>
           </a:prstGeom>
           <a:solidFill>
@@ -4928,14 +4940,14 @@
       </p:sp>
       <p:sp>
         <p:nvSpPr>
-          <p:cNvPr id="8" name="Rounded Rectangle 7"/>
+          <p:cNvPr id="9" name="Rounded Rectangle 8"/>
           <p:cNvSpPr/>
           <p:nvPr/>
         </p:nvSpPr>
         <p:spPr>
           <a:xfrm>
-            <a:off x="548640" y="1143000"/>
-            <a:ext cx="4023360" cy="384048"/>
+            <a:off x="7955279" y="1234440"/>
+            <a:ext cx="3657600" cy="402336"/>
           </a:xfrm>
           <a:prstGeom prst="roundRect">
             <a:avLst>
@@ -4943,7 +4955,7 @@
             </a:avLst>
           </a:prstGeom>
           <a:solidFill>
-            <a:srgbClr val="0F2942"/>
+            <a:srgbClr val="E11D48"/>
           </a:solidFill>
           <a:ln>
             <a:noFill/>
@@ -4973,14 +4985,14 @@
       </p:sp>
       <p:sp>
         <p:nvSpPr>
-          <p:cNvPr id="9" name="TextBox 8"/>
+          <p:cNvPr id="10" name="TextBox 9"/>
           <p:cNvSpPr txBox="1"/>
           <p:nvPr/>
         </p:nvSpPr>
         <p:spPr>
           <a:xfrm>
-            <a:off x="685800" y="1179576"/>
-            <a:ext cx="3749040" cy="320040"/>
+            <a:off x="8092440" y="1280160"/>
+            <a:ext cx="3383280" cy="320040"/>
           </a:xfrm>
           <a:prstGeom prst="rect">
             <a:avLst/>
@@ -4994,7 +5006,7 @@
           <a:lstStyle/>
           <a:p>
             <a:pPr>
-              <a:defRPr sz="1200" b="1">
+              <a:defRPr sz="1300" b="1">
                 <a:solidFill>
                   <a:srgbClr val="FFFFFF"/>
                 </a:solidFill>
@@ -5002,21 +5014,21 @@
               </a:defRPr>
             </a:pPr>
             <a:r>
-              <a:t>The Business Problem</a:t>
-            </a:r>
-          </a:p>
-        </p:txBody>
-      </p:sp>
-      <p:sp>
-        <p:nvSpPr>
-          <p:cNvPr id="10" name="TextBox 9"/>
+              <a:t>The Supply Chain Dilemma</a:t>
+            </a:r>
+          </a:p>
+        </p:txBody>
+      </p:sp>
+      <p:sp>
+        <p:nvSpPr>
+          <p:cNvPr id="11" name="TextBox 10"/>
           <p:cNvSpPr txBox="1"/>
           <p:nvPr/>
         </p:nvSpPr>
         <p:spPr>
           <a:xfrm>
-            <a:off x="685800" y="1581912"/>
-            <a:ext cx="3749040" cy="1965960"/>
+            <a:off x="8138159" y="1709928"/>
+            <a:ext cx="3291840" cy="1920240"/>
           </a:xfrm>
           <a:prstGeom prst="rect">
             <a:avLst/>
@@ -5031,9 +5043,9 @@
           <a:p>
             <a:pPr>
               <a:spcAft>
-                <a:spcPts val="400"/>
+                <a:spcPts val="600"/>
               </a:spcAft>
-              <a:defRPr sz="1100">
+              <a:defRPr sz="1200">
                 <a:solidFill>
                   <a:srgbClr val="1E293B"/>
                 </a:solidFill>
@@ -5041,15 +5053,15 @@
               </a:defRPr>
             </a:pPr>
             <a:r>
-              <a:t>• Scale: 45 Walmart stores, 81 departments (over 3,600 time series).</a:t>
+              <a:t>• Thanksgiving (+44%): Sales surge to $66.6M in a single week due to Black Friday demand.</a:t>
             </a:r>
           </a:p>
           <a:p>
             <a:pPr>
               <a:spcAft>
-                <a:spcPts val="400"/>
+                <a:spcPts val="600"/>
               </a:spcAft>
-              <a:defRPr sz="1100">
+              <a:defRPr sz="1200">
                 <a:solidFill>
                   <a:srgbClr val="1E293B"/>
                 </a:solidFill>
@@ -5057,15 +5069,15 @@
               </a:defRPr>
             </a:pPr>
             <a:r>
-              <a:t>• Volatility: Extreme sales surges during holidays (Thanksgiving, Christmas) and promotional markdown campaigns.</a:t>
+              <a:t>• Pre-Christmas (+40%): Surges to $80.9M, followed by an immediate sharp drop.</a:t>
             </a:r>
           </a:p>
           <a:p>
             <a:pPr>
               <a:spcAft>
-                <a:spcPts val="400"/>
+                <a:spcPts val="600"/>
               </a:spcAft>
-              <a:defRPr sz="1100">
+              <a:defRPr sz="1200">
                 <a:solidFill>
                   <a:srgbClr val="1E293B"/>
                 </a:solidFill>
@@ -5073,25 +5085,25 @@
               </a:defRPr>
             </a:pPr>
             <a:r>
-              <a:t>• Goal: Accurately predict Weekly_Sales to optimize inventory replenishment.</a:t>
-            </a:r>
-          </a:p>
-        </p:txBody>
-      </p:sp>
-      <p:sp>
-        <p:nvSpPr>
-          <p:cNvPr id="11" name="Rounded Rectangle 10"/>
+              <a:t>• Asymmetric Risk: Stockouts during holidays lose customers forever. Over-stocking causes costly markdowns.</a:t>
+            </a:r>
+          </a:p>
+        </p:txBody>
+      </p:sp>
+      <p:sp>
+        <p:nvSpPr>
+          <p:cNvPr id="12" name="Rounded Rectangle 11"/>
           <p:cNvSpPr/>
           <p:nvPr/>
         </p:nvSpPr>
         <p:spPr>
           <a:xfrm>
-            <a:off x="548640" y="3794760"/>
-            <a:ext cx="4023360" cy="2514600"/>
+            <a:off x="7955279" y="3886200"/>
+            <a:ext cx="3657600" cy="2423160"/>
           </a:xfrm>
           <a:prstGeom prst="roundRect">
             <a:avLst>
-              <a:gd name="adj" fmla="val 3000"/>
+              <a:gd name="adj" fmla="val 4000"/>
             </a:avLst>
           </a:prstGeom>
           <a:solidFill>
@@ -5127,14 +5139,14 @@
       </p:sp>
       <p:sp>
         <p:nvSpPr>
-          <p:cNvPr id="12" name="Rounded Rectangle 11"/>
+          <p:cNvPr id="13" name="Rounded Rectangle 12"/>
           <p:cNvSpPr/>
           <p:nvPr/>
         </p:nvSpPr>
         <p:spPr>
           <a:xfrm>
-            <a:off x="548640" y="3794760"/>
-            <a:ext cx="4023360" cy="384048"/>
+            <a:off x="7955279" y="3886200"/>
+            <a:ext cx="3657600" cy="402336"/>
           </a:xfrm>
           <a:prstGeom prst="roundRect">
             <a:avLst>
@@ -5142,7 +5154,7 @@
             </a:avLst>
           </a:prstGeom>
           <a:solidFill>
-            <a:srgbClr val="E11D48"/>
+            <a:srgbClr val="0F2942"/>
           </a:solidFill>
           <a:ln>
             <a:noFill/>
@@ -5172,14 +5184,14 @@
       </p:sp>
       <p:sp>
         <p:nvSpPr>
-          <p:cNvPr id="13" name="TextBox 12"/>
+          <p:cNvPr id="14" name="TextBox 13"/>
           <p:cNvSpPr txBox="1"/>
           <p:nvPr/>
         </p:nvSpPr>
         <p:spPr>
           <a:xfrm>
-            <a:off x="685800" y="3831336"/>
-            <a:ext cx="3749040" cy="320040"/>
+            <a:off x="8092440" y="3931920"/>
+            <a:ext cx="3383280" cy="320040"/>
           </a:xfrm>
           <a:prstGeom prst="rect">
             <a:avLst/>
@@ -5193,7 +5205,7 @@
           <a:lstStyle/>
           <a:p>
             <a:pPr>
-              <a:defRPr sz="1200" b="1">
+              <a:defRPr sz="1300" b="1">
                 <a:solidFill>
                   <a:srgbClr val="FFFFFF"/>
                 </a:solidFill>
@@ -5201,21 +5213,21 @@
               </a:defRPr>
             </a:pPr>
             <a:r>
-              <a:t>Asymmetric Supply Chain Cost</a:t>
-            </a:r>
-          </a:p>
-        </p:txBody>
-      </p:sp>
-      <p:sp>
-        <p:nvSpPr>
-          <p:cNvPr id="14" name="TextBox 13"/>
+              <a:t>The Evaluation Metric (WMAE)</a:t>
+            </a:r>
+          </a:p>
+        </p:txBody>
+      </p:sp>
+      <p:sp>
+        <p:nvSpPr>
+          <p:cNvPr id="15" name="TextBox 14"/>
           <p:cNvSpPr txBox="1"/>
           <p:nvPr/>
         </p:nvSpPr>
         <p:spPr>
           <a:xfrm>
-            <a:off x="685800" y="4233672"/>
-            <a:ext cx="3749040" cy="2011680"/>
+            <a:off x="8138159" y="4361688"/>
+            <a:ext cx="3291840" cy="1874519"/>
           </a:xfrm>
           <a:prstGeom prst="rect">
             <a:avLst/>
@@ -5230,9 +5242,9 @@
           <a:p>
             <a:pPr>
               <a:spcAft>
-                <a:spcPts val="400"/>
+                <a:spcPts val="600"/>
               </a:spcAft>
-              <a:defRPr sz="1100">
+              <a:defRPr sz="1200">
                 <a:solidFill>
                   <a:srgbClr val="1E293B"/>
                 </a:solidFill>
@@ -5240,15 +5252,15 @@
               </a:defRPr>
             </a:pPr>
             <a:r>
-              <a:t>• Stockout Risk (Under-forecasting): Running out of stock during holiday peaks causes direct revenue loss and customer dissatisfaction. This is why the competition metric (WMAE) weights holiday errors 5x higher (w = 5).</a:t>
+              <a:t>• Weighted Mean Absolute Error (WMAE):</a:t>
             </a:r>
           </a:p>
           <a:p>
             <a:pPr>
               <a:spcAft>
-                <a:spcPts val="400"/>
+                <a:spcPts val="600"/>
               </a:spcAft>
-              <a:defRPr sz="1100">
+              <a:defRPr sz="1200">
                 <a:solidFill>
                   <a:srgbClr val="1E293B"/>
                 </a:solidFill>
@@ -5256,166 +5268,15 @@
               </a:defRPr>
             </a:pPr>
             <a:r>
-              <a:t>• Holding Cost (Over-forecasting): Overstocking incurs warehouse storage fees and forces post-season clearance markdowns.</a:t>
-            </a:r>
-          </a:p>
-        </p:txBody>
-      </p:sp>
-      <p:sp>
-        <p:nvSpPr>
-          <p:cNvPr id="15" name="Rounded Rectangle 14"/>
-          <p:cNvSpPr/>
-          <p:nvPr/>
-        </p:nvSpPr>
-        <p:spPr>
-          <a:xfrm>
-            <a:off x="4846320" y="1143000"/>
-            <a:ext cx="6766560" cy="5166360"/>
-          </a:xfrm>
-          <a:prstGeom prst="roundRect">
-            <a:avLst>
-              <a:gd name="adj" fmla="val 3000"/>
-            </a:avLst>
-          </a:prstGeom>
-          <a:solidFill>
-            <a:srgbClr val="F8FAFC"/>
-          </a:solidFill>
-          <a:ln w="12700">
-            <a:solidFill>
-              <a:srgbClr val="E2E8F0"/>
-            </a:solidFill>
-          </a:ln>
-        </p:spPr>
-        <p:style>
-          <a:lnRef idx="1">
-            <a:schemeClr val="accent1"/>
-          </a:lnRef>
-          <a:fillRef idx="3">
-            <a:schemeClr val="accent1"/>
-          </a:fillRef>
-          <a:effectRef idx="2">
-            <a:schemeClr val="accent1"/>
-          </a:effectRef>
-          <a:fontRef idx="minor">
-            <a:schemeClr val="lt1"/>
-          </a:fontRef>
-        </p:style>
-        <p:txBody>
-          <a:bodyPr rtlCol="0" anchor="ctr"/>
-          <a:lstStyle/>
-          <a:p>
-            <a:pPr algn="ctr"/>
-          </a:p>
-        </p:txBody>
-      </p:sp>
-      <p:sp>
-        <p:nvSpPr>
-          <p:cNvPr id="16" name="Rounded Rectangle 15"/>
-          <p:cNvSpPr/>
-          <p:nvPr/>
-        </p:nvSpPr>
-        <p:spPr>
-          <a:xfrm>
-            <a:off x="4846320" y="1143000"/>
-            <a:ext cx="6766560" cy="384048"/>
-          </a:xfrm>
-          <a:prstGeom prst="roundRect">
-            <a:avLst>
-              <a:gd name="adj" fmla="val 8000"/>
-            </a:avLst>
-          </a:prstGeom>
-          <a:solidFill>
-            <a:srgbClr val="0071CE"/>
-          </a:solidFill>
-          <a:ln>
-            <a:noFill/>
-          </a:ln>
-        </p:spPr>
-        <p:style>
-          <a:lnRef idx="1">
-            <a:schemeClr val="accent1"/>
-          </a:lnRef>
-          <a:fillRef idx="3">
-            <a:schemeClr val="accent1"/>
-          </a:fillRef>
-          <a:effectRef idx="2">
-            <a:schemeClr val="accent1"/>
-          </a:effectRef>
-          <a:fontRef idx="minor">
-            <a:schemeClr val="lt1"/>
-          </a:fontRef>
-        </p:style>
-        <p:txBody>
-          <a:bodyPr rtlCol="0" anchor="ctr"/>
-          <a:lstStyle/>
-          <a:p>
-            <a:pPr algn="ctr"/>
-          </a:p>
-        </p:txBody>
-      </p:sp>
-      <p:sp>
-        <p:nvSpPr>
-          <p:cNvPr id="17" name="TextBox 16"/>
-          <p:cNvSpPr txBox="1"/>
-          <p:nvPr/>
-        </p:nvSpPr>
-        <p:spPr>
-          <a:xfrm>
-            <a:off x="4983480" y="1179576"/>
-            <a:ext cx="6492240" cy="320040"/>
-          </a:xfrm>
-          <a:prstGeom prst="rect">
-            <a:avLst/>
-          </a:prstGeom>
-          <a:noFill/>
-        </p:spPr>
-        <p:txBody>
-          <a:bodyPr wrap="none">
-            <a:spAutoFit/>
-          </a:bodyPr>
-          <a:lstStyle/>
-          <a:p>
-            <a:pPr>
-              <a:defRPr sz="1200" b="1">
-                <a:solidFill>
-                  <a:srgbClr val="FFFFFF"/>
-                </a:solidFill>
-                <a:latin typeface="Calibri"/>
-              </a:defRPr>
-            </a:pPr>
-            <a:r>
-              <a:t>End-to-End KDD Implementation Workflow</a:t>
-            </a:r>
-          </a:p>
-        </p:txBody>
-      </p:sp>
-      <p:sp>
-        <p:nvSpPr>
-          <p:cNvPr id="18" name="TextBox 17"/>
-          <p:cNvSpPr txBox="1"/>
-          <p:nvPr/>
-        </p:nvSpPr>
-        <p:spPr>
-          <a:xfrm>
-            <a:off x="4983480" y="1581912"/>
-            <a:ext cx="6492240" cy="4663440"/>
-          </a:xfrm>
-          <a:prstGeom prst="rect">
-            <a:avLst/>
-          </a:prstGeom>
-          <a:noFill/>
-        </p:spPr>
-        <p:txBody>
-          <a:bodyPr wrap="square">
-            <a:spAutoFit/>
-          </a:bodyPr>
-          <a:lstStyle/>
+              <a:t>• Holiday Weeks have 5x weight (w = 5).</a:t>
+            </a:r>
+          </a:p>
           <a:p>
             <a:pPr>
               <a:spcAft>
-                <a:spcPts val="400"/>
+                <a:spcPts val="600"/>
               </a:spcAft>
-              <a:defRPr sz="1100">
+              <a:defRPr sz="1200">
                 <a:solidFill>
                   <a:srgbClr val="1E293B"/>
                 </a:solidFill>
@@ -5423,15 +5284,15 @@
               </a:defRPr>
             </a:pPr>
             <a:r>
-              <a:t>1. Data Ingestion: Merged 4 relational tables (train.csv, features.csv, stores.csv, test.csv) into 421,570 unified rows.</a:t>
+              <a:t>• Regular Weeks have 1x weight (w = 1).</a:t>
             </a:r>
           </a:p>
           <a:p>
             <a:pPr>
               <a:spcAft>
-                <a:spcPts val="400"/>
+                <a:spcPts val="600"/>
               </a:spcAft>
-              <a:defRPr sz="1100">
+              <a:defRPr sz="1200">
                 <a:solidFill>
                   <a:srgbClr val="1E293B"/>
                 </a:solidFill>
@@ -5439,87 +5300,7 @@
               </a:defRPr>
             </a:pPr>
             <a:r>
-              <a:t>2. Preprocessing: Structural zero-imputation for MarkDown1–5; store-grouped fill for CPI &amp; Unemployment; floored 1,285 negative sales &amp; treated outliers.</a:t>
-            </a:r>
-          </a:p>
-          <a:p>
-            <a:pPr>
-              <a:spcAft>
-                <a:spcPts val="400"/>
-              </a:spcAft>
-              <a:defRPr sz="1100">
-                <a:solidFill>
-                  <a:srgbClr val="1E293B"/>
-                </a:solidFill>
-                <a:latin typeface="Calibri"/>
-              </a:defRPr>
-            </a:pPr>
-            <a:r>
-              <a:t>3. Feature Engineering: Created 43 leak-free features (Lags 1–52, Rolling Means, Holiday flags, Fourier cyclical encodings).</a:t>
-            </a:r>
-          </a:p>
-          <a:p>
-            <a:pPr>
-              <a:spcAft>
-                <a:spcPts val="400"/>
-              </a:spcAft>
-              <a:defRPr sz="1100">
-                <a:solidFill>
-                  <a:srgbClr val="1E293B"/>
-                </a:solidFill>
-                <a:latin typeface="Calibri"/>
-              </a:defRPr>
-            </a:pPr>
-            <a:r>
-              <a:t>4. Exploratory Data Analysis: Quantified store size elasticity (r = 0.81), format hierarchy (Types A, B, C), and holiday revenue lifts.</a:t>
-            </a:r>
-          </a:p>
-          <a:p>
-            <a:pPr>
-              <a:spcAft>
-                <a:spcPts val="400"/>
-              </a:spcAft>
-              <a:defRPr sz="1100">
-                <a:solidFill>
-                  <a:srgbClr val="1E293B"/>
-                </a:solidFill>
-                <a:latin typeface="Calibri"/>
-              </a:defRPr>
-            </a:pPr>
-            <a:r>
-              <a:t>5. Model Training: Strict chronological split (2011-11-25); trained Baseline Ridge, Random Forest, XGBoost, and LightGBM with w=5 sample weights.</a:t>
-            </a:r>
-          </a:p>
-          <a:p>
-            <a:pPr>
-              <a:spcAft>
-                <a:spcPts val="400"/>
-              </a:spcAft>
-              <a:defRPr sz="1100">
-                <a:solidFill>
-                  <a:srgbClr val="1E293B"/>
-                </a:solidFill>
-                <a:latin typeface="Calibri"/>
-              </a:defRPr>
-            </a:pPr>
-            <a:r>
-              <a:t>6. Model Evaluation: Assessed out-of-sample performance via WMAE ($w=5$), RMSE, MAE, and R².</a:t>
-            </a:r>
-          </a:p>
-          <a:p>
-            <a:pPr>
-              <a:spcAft>
-                <a:spcPts val="400"/>
-              </a:spcAft>
-              <a:defRPr sz="1100">
-                <a:solidFill>
-                  <a:srgbClr val="1E293B"/>
-                </a:solidFill>
-                <a:latin typeface="Calibri"/>
-              </a:defRPr>
-            </a:pPr>
-            <a:r>
-              <a:t>7. Business Interpretation: Analyzed feature gain attribution and translated error reduction into $31.7M in inventory cost savings.</a:t>
+              <a:t>• Models must prioritize holiday accuracy above all else to optimize inventory.</a:t>
             </a:r>
           </a:p>
         </p:txBody>
@@ -5594,7 +5375,7 @@
         <p:spPr>
           <a:xfrm>
             <a:off x="0" y="0"/>
-            <a:ext cx="12191695" cy="914400"/>
+            <a:ext cx="12191695" cy="960120"/>
           </a:xfrm>
           <a:prstGeom prst="rect">
             <a:avLst/>
@@ -5636,8 +5417,8 @@
         </p:nvSpPr>
         <p:spPr>
           <a:xfrm>
-            <a:off x="0" y="914400"/>
-            <a:ext cx="12191695" cy="45720"/>
+            <a:off x="0" y="960120"/>
+            <a:ext cx="12191695" cy="54864"/>
           </a:xfrm>
           <a:prstGeom prst="rect">
             <a:avLst/>
@@ -5679,8 +5460,8 @@
         </p:nvSpPr>
         <p:spPr>
           <a:xfrm>
-            <a:off x="548640" y="91440"/>
-            <a:ext cx="9601200" cy="777240"/>
+            <a:off x="594360" y="109728"/>
+            <a:ext cx="10058400" cy="777240"/>
           </a:xfrm>
           <a:prstGeom prst="rect">
             <a:avLst/>
@@ -5694,7 +5475,7 @@
           <a:lstStyle/>
           <a:p>
             <a:pPr>
-              <a:defRPr sz="2200" b="1">
+              <a:defRPr sz="2300" b="1">
                 <a:solidFill>
                   <a:srgbClr val="FFFFFF"/>
                 </a:solidFill>
@@ -5702,12 +5483,12 @@
               </a:defRPr>
             </a:pPr>
             <a:r>
-              <a:t>2. Data Preprocessing: Missing MarkDowns &amp; Outliers</a:t>
+              <a:t>2. Data Preprocessing: MarkDowns &amp; Outlier Treatment</a:t>
             </a:r>
           </a:p>
           <a:p>
             <a:pPr>
-              <a:defRPr sz="1150">
+              <a:defRPr sz="1200">
                 <a:solidFill>
                   <a:srgbClr val="BAE6FD"/>
                 </a:solidFill>
@@ -5715,7 +5496,7 @@
               </a:defRPr>
             </a:pPr>
             <a:r>
-              <a:t>Cleaning 421,570 Records While Preserving Authentic Holiday Demand Spikes</a:t>
+              <a:t>Handling Missing Promotional Records and Anomaly Returns Without Biasing Holiday Spikes</a:t>
             </a:r>
           </a:p>
         </p:txBody>
@@ -5728,8 +5509,8 @@
         </p:nvSpPr>
         <p:spPr>
           <a:xfrm>
-            <a:off x="548640" y="6510528"/>
-            <a:ext cx="11094415" cy="274320"/>
+            <a:off x="594360" y="6510528"/>
+            <a:ext cx="10972800" cy="274320"/>
           </a:xfrm>
           <a:prstGeom prst="rect">
             <a:avLst/>
@@ -5758,7 +5539,7 @@
       </p:sp>
       <p:pic>
         <p:nvPicPr>
-          <p:cNvPr id="7" name="Picture 6" descr="fig2_outlier_and_markdown_analysis.png"/>
+          <p:cNvPr id="7" name="Picture 6" descr="chart_preprocessing_simple.png"/>
           <p:cNvPicPr>
             <a:picLocks noChangeAspect="1"/>
           </p:cNvPicPr>
@@ -5772,8 +5553,8 @@
         </p:blipFill>
         <p:spPr>
           <a:xfrm>
-            <a:off x="548640" y="1188720"/>
-            <a:ext cx="7315200" cy="2256710"/>
+            <a:off x="594360" y="1234440"/>
+            <a:ext cx="7132320" cy="4027663"/>
           </a:xfrm>
           <a:prstGeom prst="rect">
             <a:avLst/>
@@ -5788,12 +5569,12 @@
         </p:nvSpPr>
         <p:spPr>
           <a:xfrm>
-            <a:off x="8046720" y="1188720"/>
-            <a:ext cx="3566160" cy="2423160"/>
+            <a:off x="7955279" y="1234440"/>
+            <a:ext cx="3657600" cy="2468880"/>
           </a:xfrm>
           <a:prstGeom prst="roundRect">
             <a:avLst>
-              <a:gd name="adj" fmla="val 3000"/>
+              <a:gd name="adj" fmla="val 4000"/>
             </a:avLst>
           </a:prstGeom>
           <a:solidFill>
@@ -5835,8 +5616,8 @@
         </p:nvSpPr>
         <p:spPr>
           <a:xfrm>
-            <a:off x="8046720" y="1188720"/>
-            <a:ext cx="3566160" cy="384048"/>
+            <a:off x="7955279" y="1234440"/>
+            <a:ext cx="3657600" cy="402336"/>
           </a:xfrm>
           <a:prstGeom prst="roundRect">
             <a:avLst>
@@ -5880,8 +5661,8 @@
         </p:nvSpPr>
         <p:spPr>
           <a:xfrm>
-            <a:off x="8183880" y="1225296"/>
-            <a:ext cx="3291840" cy="320040"/>
+            <a:off x="8092440" y="1280160"/>
+            <a:ext cx="3383280" cy="320040"/>
           </a:xfrm>
           <a:prstGeom prst="rect">
             <a:avLst/>
@@ -5895,7 +5676,7 @@
           <a:lstStyle/>
           <a:p>
             <a:pPr>
-              <a:defRPr sz="1200" b="1">
+              <a:defRPr sz="1300" b="1">
                 <a:solidFill>
                   <a:srgbClr val="FFFFFF"/>
                 </a:solidFill>
@@ -5903,7 +5684,7 @@
               </a:defRPr>
             </a:pPr>
             <a:r>
-              <a:t>MarkDown Imputation Strategy</a:t>
+              <a:t>1. MarkDown Imputation</a:t>
             </a:r>
           </a:p>
         </p:txBody>
@@ -5916,8 +5697,8 @@
         </p:nvSpPr>
         <p:spPr>
           <a:xfrm>
-            <a:off x="8183880" y="1627632"/>
-            <a:ext cx="3291840" cy="1920239"/>
+            <a:off x="8138159" y="1709928"/>
+            <a:ext cx="3291840" cy="1920240"/>
           </a:xfrm>
           <a:prstGeom prst="rect">
             <a:avLst/>
@@ -5932,9 +5713,9 @@
           <a:p>
             <a:pPr>
               <a:spcAft>
-                <a:spcPts val="400"/>
+                <a:spcPts val="600"/>
               </a:spcAft>
-              <a:defRPr sz="1100">
+              <a:defRPr sz="1200">
                 <a:solidFill>
                   <a:srgbClr val="1E293B"/>
                 </a:solidFill>
@@ -5942,15 +5723,15 @@
               </a:defRPr>
             </a:pPr>
             <a:r>
-              <a:t>• Pre-Nov 2011 Missingness: MarkDown1–5 have 64% to 74% missing values because Walmart only started tracking them in Nov 2011.</a:t>
+              <a:t>• 64%–74% Missing: MarkDown1–5 only started being tracked in November 2011.</a:t>
             </a:r>
           </a:p>
           <a:p>
             <a:pPr>
               <a:spcAft>
-                <a:spcPts val="400"/>
+                <a:spcPts val="600"/>
               </a:spcAft>
-              <a:defRPr sz="1100">
+              <a:defRPr sz="1200">
                 <a:solidFill>
                   <a:srgbClr val="1E293B"/>
                 </a:solidFill>
@@ -5958,15 +5739,15 @@
               </a:defRPr>
             </a:pPr>
             <a:r>
-              <a:t>• Treatment: Extracted binary Has_MarkDown and Active_MarkDown_Count flags, then imputed 0.0 (structural absence of promo).</a:t>
+              <a:t>• Solution: Extracted binary 'Has_MarkDown' and count indicators before imputing 0.0.</a:t>
             </a:r>
           </a:p>
           <a:p>
             <a:pPr>
               <a:spcAft>
-                <a:spcPts val="400"/>
+                <a:spcPts val="600"/>
               </a:spcAft>
-              <a:defRPr sz="1100">
+              <a:defRPr sz="1200">
                 <a:solidFill>
                   <a:srgbClr val="1E293B"/>
                 </a:solidFill>
@@ -5974,7 +5755,7 @@
               </a:defRPr>
             </a:pPr>
             <a:r>
-              <a:t>• CPI &amp; Unemployment: Missing in late test weeks; imputed using store-level forward/backward fill.</a:t>
+              <a:t>• Result: The model knows whether a promotion was active or inactive.</a:t>
             </a:r>
           </a:p>
         </p:txBody>
@@ -5987,12 +5768,12 @@
         </p:nvSpPr>
         <p:spPr>
           <a:xfrm>
-            <a:off x="8046720" y="3794760"/>
-            <a:ext cx="3566160" cy="2560320"/>
+            <a:off x="7955279" y="3886200"/>
+            <a:ext cx="3657600" cy="2423160"/>
           </a:xfrm>
           <a:prstGeom prst="roundRect">
             <a:avLst>
-              <a:gd name="adj" fmla="val 3000"/>
+              <a:gd name="adj" fmla="val 4000"/>
             </a:avLst>
           </a:prstGeom>
           <a:solidFill>
@@ -6034,8 +5815,8 @@
         </p:nvSpPr>
         <p:spPr>
           <a:xfrm>
-            <a:off x="8046720" y="3794760"/>
-            <a:ext cx="3566160" cy="384048"/>
+            <a:off x="7955279" y="3886200"/>
+            <a:ext cx="3657600" cy="402336"/>
           </a:xfrm>
           <a:prstGeom prst="roundRect">
             <a:avLst>
@@ -6079,8 +5860,8 @@
         </p:nvSpPr>
         <p:spPr>
           <a:xfrm>
-            <a:off x="8183880" y="3831336"/>
-            <a:ext cx="3291840" cy="320040"/>
+            <a:off x="8092440" y="3931920"/>
+            <a:ext cx="3383280" cy="320040"/>
           </a:xfrm>
           <a:prstGeom prst="rect">
             <a:avLst/>
@@ -6094,7 +5875,7 @@
           <a:lstStyle/>
           <a:p>
             <a:pPr>
-              <a:defRPr sz="1200" b="1">
+              <a:defRPr sz="1300" b="1">
                 <a:solidFill>
                   <a:srgbClr val="FFFFFF"/>
                 </a:solidFill>
@@ -6102,7 +5883,7 @@
               </a:defRPr>
             </a:pPr>
             <a:r>
-              <a:t>Negative Sales &amp; Outlier Treatment</a:t>
+              <a:t>2. Returns &amp; Outliers</a:t>
             </a:r>
           </a:p>
         </p:txBody>
@@ -6115,8 +5896,8 @@
         </p:nvSpPr>
         <p:spPr>
           <a:xfrm>
-            <a:off x="8183880" y="4233672"/>
-            <a:ext cx="3291840" cy="2057400"/>
+            <a:off x="8138159" y="4361688"/>
+            <a:ext cx="3291840" cy="1874519"/>
           </a:xfrm>
           <a:prstGeom prst="rect">
             <a:avLst/>
@@ -6131,9 +5912,9 @@
           <a:p>
             <a:pPr>
               <a:spcAft>
-                <a:spcPts val="400"/>
+                <a:spcPts val="600"/>
               </a:spcAft>
-              <a:defRPr sz="1100">
+              <a:defRPr sz="1200">
                 <a:solidFill>
                   <a:srgbClr val="1E293B"/>
                 </a:solidFill>
@@ -6141,15 +5922,15 @@
               </a:defRPr>
             </a:pPr>
             <a:r>
-              <a:t>• Negative Returns (1,285 rows): 0.3% of sales were negative due to customer returns and accounting credits. Floored at $0.00.</a:t>
+              <a:t>• Negative Returns (1,285 rows): Customer returns caused negative sales. Floored at $0.00.</a:t>
             </a:r>
           </a:p>
           <a:p>
             <a:pPr>
               <a:spcAft>
-                <a:spcPts val="400"/>
+                <a:spcPts val="600"/>
               </a:spcAft>
-              <a:defRPr sz="1100">
+              <a:defRPr sz="1200">
                 <a:solidFill>
                   <a:srgbClr val="1E293B"/>
                 </a:solidFill>
@@ -6157,7 +5938,7 @@
               </a:defRPr>
             </a:pPr>
             <a:r>
-              <a:t>• Preserving Holiday Spikes: Standard IQR filtering would incorrectly delete genuine Black Friday surges. Instead, we winsorized non-holiday upper-tail records (&gt;99.95th percentile, $183K) while keeping holiday records intact.</a:t>
+              <a:t>• Preserving Holidays: Standard outlier removal would delete genuine Black Friday spikes. We capped non-holiday outliers at $183K while keeping holiday spikes intact.</a:t>
             </a:r>
           </a:p>
         </p:txBody>
@@ -6232,7 +6013,7 @@
         <p:spPr>
           <a:xfrm>
             <a:off x="0" y="0"/>
-            <a:ext cx="12191695" cy="914400"/>
+            <a:ext cx="12191695" cy="960120"/>
           </a:xfrm>
           <a:prstGeom prst="rect">
             <a:avLst/>
@@ -6274,8 +6055,8 @@
         </p:nvSpPr>
         <p:spPr>
           <a:xfrm>
-            <a:off x="0" y="914400"/>
-            <a:ext cx="12191695" cy="45720"/>
+            <a:off x="0" y="960120"/>
+            <a:ext cx="12191695" cy="54864"/>
           </a:xfrm>
           <a:prstGeom prst="rect">
             <a:avLst/>
@@ -6317,8 +6098,8 @@
         </p:nvSpPr>
         <p:spPr>
           <a:xfrm>
-            <a:off x="548640" y="91440"/>
-            <a:ext cx="9601200" cy="777240"/>
+            <a:off x="594360" y="109728"/>
+            <a:ext cx="10058400" cy="777240"/>
           </a:xfrm>
           <a:prstGeom prst="rect">
             <a:avLst/>
@@ -6332,7 +6113,7 @@
           <a:lstStyle/>
           <a:p>
             <a:pPr>
-              <a:defRPr sz="2200" b="1">
+              <a:defRPr sz="2300" b="1">
                 <a:solidFill>
                   <a:srgbClr val="FFFFFF"/>
                 </a:solidFill>
@@ -6340,12 +6121,12 @@
               </a:defRPr>
             </a:pPr>
             <a:r>
-              <a:t>3. Feature Engineering: 43 Leak-Free Predictors</a:t>
+              <a:t>3. Feature Engineering: The 43 Predictive Features</a:t>
             </a:r>
           </a:p>
           <a:p>
             <a:pPr>
-              <a:defRPr sz="1150">
+              <a:defRPr sz="1200">
                 <a:solidFill>
                   <a:srgbClr val="BAE6FD"/>
                 </a:solidFill>
@@ -6353,7 +6134,7 @@
               </a:defRPr>
             </a:pPr>
             <a:r>
-              <a:t>Multi-Horizon Autoregression, Rolling Trends, Holiday Flags &amp; Cyclical Fourier Transforms</a:t>
+              <a:t>How Autoregressive Lags and Calendar Signals Power Accurate Forecasts</a:t>
             </a:r>
           </a:p>
         </p:txBody>
@@ -6366,8 +6147,8 @@
         </p:nvSpPr>
         <p:spPr>
           <a:xfrm>
-            <a:off x="548640" y="6510528"/>
-            <a:ext cx="11094415" cy="274320"/>
+            <a:off x="594360" y="6510528"/>
+            <a:ext cx="10972800" cy="274320"/>
           </a:xfrm>
           <a:prstGeom prst="rect">
             <a:avLst/>
@@ -6396,7 +6177,7 @@
       </p:sp>
       <p:pic>
         <p:nvPicPr>
-          <p:cNvPr id="7" name="Picture 6" descr="fig4_correlation_matrix.png"/>
+          <p:cNvPr id="7" name="Picture 6" descr="chart2_top_features.png"/>
           <p:cNvPicPr>
             <a:picLocks noChangeAspect="1"/>
           </p:cNvPicPr>
@@ -6410,8 +6191,8 @@
         </p:blipFill>
         <p:spPr>
           <a:xfrm>
-            <a:off x="548640" y="1143000"/>
-            <a:ext cx="5212080" cy="4453178"/>
+            <a:off x="594360" y="1234440"/>
+            <a:ext cx="7132320" cy="4027663"/>
           </a:xfrm>
           <a:prstGeom prst="rect">
             <a:avLst/>
@@ -6426,12 +6207,12 @@
         </p:nvSpPr>
         <p:spPr>
           <a:xfrm>
-            <a:off x="5943600" y="1143000"/>
-            <a:ext cx="5669280" cy="2468880"/>
+            <a:off x="7955279" y="1234440"/>
+            <a:ext cx="3657600" cy="2468880"/>
           </a:xfrm>
           <a:prstGeom prst="roundRect">
             <a:avLst>
-              <a:gd name="adj" fmla="val 3000"/>
+              <a:gd name="adj" fmla="val 4000"/>
             </a:avLst>
           </a:prstGeom>
           <a:solidFill>
@@ -6473,8 +6254,8 @@
         </p:nvSpPr>
         <p:spPr>
           <a:xfrm>
-            <a:off x="5943600" y="1143000"/>
-            <a:ext cx="5669280" cy="384048"/>
+            <a:off x="7955279" y="1234440"/>
+            <a:ext cx="3657600" cy="402336"/>
           </a:xfrm>
           <a:prstGeom prst="roundRect">
             <a:avLst>
@@ -6518,8 +6299,8 @@
         </p:nvSpPr>
         <p:spPr>
           <a:xfrm>
-            <a:off x="6080760" y="1179576"/>
-            <a:ext cx="5394960" cy="320040"/>
+            <a:off x="8092440" y="1280160"/>
+            <a:ext cx="3383280" cy="320040"/>
           </a:xfrm>
           <a:prstGeom prst="rect">
             <a:avLst/>
@@ -6533,7 +6314,7 @@
           <a:lstStyle/>
           <a:p>
             <a:pPr>
-              <a:defRPr sz="1200" b="1">
+              <a:defRPr sz="1300" b="1">
                 <a:solidFill>
                   <a:srgbClr val="FFFFFF"/>
                 </a:solidFill>
@@ -6541,7 +6322,7 @@
               </a:defRPr>
             </a:pPr>
             <a:r>
-              <a:t>Feature Families Constructed</a:t>
+              <a:t>Top Predictive Drivers</a:t>
             </a:r>
           </a:p>
         </p:txBody>
@@ -6554,8 +6335,8 @@
         </p:nvSpPr>
         <p:spPr>
           <a:xfrm>
-            <a:off x="6080760" y="1581912"/>
-            <a:ext cx="5394960" cy="1965960"/>
+            <a:off x="8138159" y="1709928"/>
+            <a:ext cx="3291840" cy="1920240"/>
           </a:xfrm>
           <a:prstGeom prst="rect">
             <a:avLst/>
@@ -6570,9 +6351,9 @@
           <a:p>
             <a:pPr>
               <a:spcAft>
-                <a:spcPts val="400"/>
+                <a:spcPts val="600"/>
               </a:spcAft>
-              <a:defRPr sz="1100">
+              <a:defRPr sz="1200">
                 <a:solidFill>
                   <a:srgbClr val="1E293B"/>
                 </a:solidFill>
@@ -6580,15 +6361,15 @@
               </a:defRPr>
             </a:pPr>
             <a:r>
-              <a:t>1. Autoregressive Lags: Lag_1 (t-1 wk, r = 0.95), Lag_2 (bi-weekly), Lag_4 (monthly, r = 0.94), and Lag_52 (year-over-year seasonal anchor, r = 0.97).</a:t>
+              <a:t>• #1: Sales 1 Year Ago (Lag 52): Contributes 40.9% of model gain! Department sales from the exact same week last year anchor seasonality.</a:t>
             </a:r>
           </a:p>
           <a:p>
             <a:pPr>
               <a:spcAft>
-                <a:spcPts val="400"/>
+                <a:spcPts val="600"/>
               </a:spcAft>
-              <a:defRPr sz="1100">
+              <a:defRPr sz="1200">
                 <a:solidFill>
                   <a:srgbClr val="1E293B"/>
                 </a:solidFill>
@@ -6596,15 +6377,15 @@
               </a:defRPr>
             </a:pPr>
             <a:r>
-              <a:t>2. Leak-Free Rolling Windows: Shifted by t-1 to prevent target leakage: Rolling_Mean_4, Rolling_Std_4, Rolling_Mean_12, and Momentum_1_4.</a:t>
+              <a:t>• #2 &amp; #3: Recent Trends (Lag 1 &amp; 4-Wk Avg): Combine for 40% of gain, capturing recent momentum and store traffic.</a:t>
             </a:r>
           </a:p>
           <a:p>
             <a:pPr>
               <a:spcAft>
-                <a:spcPts val="400"/>
+                <a:spcPts val="600"/>
               </a:spcAft>
-              <a:defRPr sz="1100">
+              <a:defRPr sz="1200">
                 <a:solidFill>
                   <a:srgbClr val="1E293B"/>
                 </a:solidFill>
@@ -6612,23 +6393,7 @@
               </a:defRPr>
             </a:pPr>
             <a:r>
-              <a:t>3. Specific Holiday Events: Binary flags for Super Bowl (W6), Labor Day (W36), Thanksgiving (W47, +44% sales lift), Christmas (W52), and Pre-Christmas Peak (W49–51, +40% sales lift).</a:t>
-            </a:r>
-          </a:p>
-          <a:p>
-            <a:pPr>
-              <a:spcAft>
-                <a:spcPts val="400"/>
-              </a:spcAft>
-              <a:defRPr sz="1100">
-                <a:solidFill>
-                  <a:srgbClr val="1E293B"/>
-                </a:solidFill>
-                <a:latin typeface="Calibri"/>
-              </a:defRPr>
-            </a:pPr>
-            <a:r>
-              <a:t>4. Fourier Cyclical Encodings: sin/cos transforms of Week and Month to capture continuous seasonal cycles.</a:t>
+              <a:t>• #4: Holiday Flags: Thanksgiving (+44%) and Christmas flags prevent holiday under-forecasting.</a:t>
             </a:r>
           </a:p>
         </p:txBody>
@@ -6641,12 +6406,12 @@
         </p:nvSpPr>
         <p:spPr>
           <a:xfrm>
-            <a:off x="5943600" y="3794760"/>
-            <a:ext cx="5669280" cy="2514600"/>
+            <a:off x="7955279" y="3886200"/>
+            <a:ext cx="3657600" cy="2423160"/>
           </a:xfrm>
           <a:prstGeom prst="roundRect">
             <a:avLst>
-              <a:gd name="adj" fmla="val 3000"/>
+              <a:gd name="adj" fmla="val 4000"/>
             </a:avLst>
           </a:prstGeom>
           <a:solidFill>
@@ -6688,8 +6453,8 @@
         </p:nvSpPr>
         <p:spPr>
           <a:xfrm>
-            <a:off x="5943600" y="3794760"/>
-            <a:ext cx="5669280" cy="384048"/>
+            <a:off x="7955279" y="3886200"/>
+            <a:ext cx="3657600" cy="402336"/>
           </a:xfrm>
           <a:prstGeom prst="roundRect">
             <a:avLst>
@@ -6733,8 +6498,8 @@
         </p:nvSpPr>
         <p:spPr>
           <a:xfrm>
-            <a:off x="6080760" y="3831336"/>
-            <a:ext cx="5394960" cy="320040"/>
+            <a:off x="8092440" y="3931920"/>
+            <a:ext cx="3383280" cy="320040"/>
           </a:xfrm>
           <a:prstGeom prst="rect">
             <a:avLst/>
@@ -6748,7 +6513,7 @@
           <a:lstStyle/>
           <a:p>
             <a:pPr>
-              <a:defRPr sz="1200" b="1">
+              <a:defRPr sz="1300" b="1">
                 <a:solidFill>
                   <a:srgbClr val="FFFFFF"/>
                 </a:solidFill>
@@ -6756,7 +6521,7 @@
               </a:defRPr>
             </a:pPr>
             <a:r>
-              <a:t>Correlation Insights (Figure at Left)</a:t>
+              <a:t>Zero Data Leakage</a:t>
             </a:r>
           </a:p>
         </p:txBody>
@@ -6769,8 +6534,8 @@
         </p:nvSpPr>
         <p:spPr>
           <a:xfrm>
-            <a:off x="6080760" y="4233672"/>
-            <a:ext cx="5394960" cy="2011680"/>
+            <a:off x="8138159" y="4361688"/>
+            <a:ext cx="3291840" cy="1874519"/>
           </a:xfrm>
           <a:prstGeom prst="rect">
             <a:avLst/>
@@ -6785,9 +6550,9 @@
           <a:p>
             <a:pPr>
               <a:spcAft>
-                <a:spcPts val="400"/>
+                <a:spcPts val="600"/>
               </a:spcAft>
-              <a:defRPr sz="1100">
+              <a:defRPr sz="1200">
                 <a:solidFill>
                   <a:srgbClr val="1E293B"/>
                 </a:solidFill>
@@ -6795,15 +6560,15 @@
               </a:defRPr>
             </a:pPr>
             <a:r>
-              <a:t>• Strongest Drivers: Lag_52 (r = 0.97), Rolling_Mean_4 (r = 0.96), and Lag_1 (r = 0.95) have the highest linear correlation with Weekly_Sales.</a:t>
+              <a:t>• Rolling Windows Shifted: All rolling statistics were computed on t-1 shifted data so no future sales leak into the model.</a:t>
             </a:r>
           </a:p>
           <a:p>
             <a:pPr>
               <a:spcAft>
-                <a:spcPts val="400"/>
+                <a:spcPts val="600"/>
               </a:spcAft>
-              <a:defRPr sz="1100">
+              <a:defRPr sz="1200">
                 <a:solidFill>
                   <a:srgbClr val="1E293B"/>
                 </a:solidFill>
@@ -6811,23 +6576,7 @@
               </a:defRPr>
             </a:pPr>
             <a:r>
-              <a:t>• Store Structure: Store physical size strongly correlates with sales (r = 0.81) across Type A Supercenters ($1.45M/wk), Type B Discount ($0.79M/wk), and Type C Neighborhood ($0.46M/wk).</a:t>
-            </a:r>
-          </a:p>
-          <a:p>
-            <a:pPr>
-              <a:spcAft>
-                <a:spcPts val="400"/>
-              </a:spcAft>
-              <a:defRPr sz="1100">
-                <a:solidFill>
-                  <a:srgbClr val="1E293B"/>
-                </a:solidFill>
-                <a:latin typeface="Calibri"/>
-              </a:defRPr>
-            </a:pPr>
-            <a:r>
-              <a:t>• No Look-Ahead Bias: Historical store-dept target statistics were computed strictly on the training partition.</a:t>
+              <a:t>• Strict Split: Historical store target baselines were calculated exclusively on the training set prior to November 2011.</a:t>
             </a:r>
           </a:p>
         </p:txBody>
@@ -6902,7 +6651,7 @@
         <p:spPr>
           <a:xfrm>
             <a:off x="0" y="0"/>
-            <a:ext cx="12191695" cy="914400"/>
+            <a:ext cx="12191695" cy="960120"/>
           </a:xfrm>
           <a:prstGeom prst="rect">
             <a:avLst/>
@@ -6944,8 +6693,8 @@
         </p:nvSpPr>
         <p:spPr>
           <a:xfrm>
-            <a:off x="0" y="914400"/>
-            <a:ext cx="12191695" cy="45720"/>
+            <a:off x="0" y="960120"/>
+            <a:ext cx="12191695" cy="54864"/>
           </a:xfrm>
           <a:prstGeom prst="rect">
             <a:avLst/>
@@ -6987,8 +6736,8 @@
         </p:nvSpPr>
         <p:spPr>
           <a:xfrm>
-            <a:off x="548640" y="91440"/>
-            <a:ext cx="9601200" cy="777240"/>
+            <a:off x="594360" y="109728"/>
+            <a:ext cx="10058400" cy="777240"/>
           </a:xfrm>
           <a:prstGeom prst="rect">
             <a:avLst/>
@@ -7002,7 +6751,7 @@
           <a:lstStyle/>
           <a:p>
             <a:pPr>
-              <a:defRPr sz="2200" b="1">
+              <a:defRPr sz="2300" b="1">
                 <a:solidFill>
                   <a:srgbClr val="FFFFFF"/>
                 </a:solidFill>
@@ -7010,12 +6759,12 @@
               </a:defRPr>
             </a:pPr>
             <a:r>
-              <a:t>4. Model Benchmarking &amp; Evaluation (WMAE, RMSE, R²)</a:t>
+              <a:t>4. Model Benchmarking: LightGBM Crushes Baseline</a:t>
             </a:r>
           </a:p>
           <a:p>
             <a:pPr>
-              <a:defRPr sz="1150">
+              <a:defRPr sz="1200">
                 <a:solidFill>
                   <a:srgbClr val="BAE6FD"/>
                 </a:solidFill>
@@ -7023,7 +6772,7 @@
               </a:defRPr>
             </a:pPr>
             <a:r>
-              <a:t>Evaluating on 145,237 Unseen Dept-Weeks Across All 4 Holiday Events</a:t>
+              <a:t>Evaluating on 145,237 Out-of-Sample Validation Records (49 Full Weeks)</a:t>
             </a:r>
           </a:p>
         </p:txBody>
@@ -7036,8 +6785,8 @@
         </p:nvSpPr>
         <p:spPr>
           <a:xfrm>
-            <a:off x="548640" y="6510528"/>
-            <a:ext cx="11094415" cy="274320"/>
+            <a:off x="594360" y="6510528"/>
+            <a:ext cx="10972800" cy="274320"/>
           </a:xfrm>
           <a:prstGeom prst="rect">
             <a:avLst/>
@@ -7066,7 +6815,7 @@
       </p:sp>
       <p:pic>
         <p:nvPicPr>
-          <p:cNvPr id="7" name="Picture 6" descr="fig5_model_comparison.png"/>
+          <p:cNvPr id="7" name="Picture 6" descr="chart3_model_wmae.png"/>
           <p:cNvPicPr>
             <a:picLocks noChangeAspect="1"/>
           </p:cNvPicPr>
@@ -7080,1016 +6829,428 @@
         </p:blipFill>
         <p:spPr>
           <a:xfrm>
-            <a:off x="548640" y="1097280"/>
-            <a:ext cx="11094415" cy="3376293"/>
+            <a:off x="594360" y="1234440"/>
+            <a:ext cx="7132320" cy="4027663"/>
           </a:xfrm>
           <a:prstGeom prst="rect">
             <a:avLst/>
           </a:prstGeom>
         </p:spPr>
       </p:pic>
-      <p:graphicFrame>
-        <p:nvGraphicFramePr>
-          <p:cNvPr id="8" name="Table 7"/>
-          <p:cNvGraphicFramePr>
-            <a:graphicFrameLocks noGrp="1"/>
-          </p:cNvGraphicFramePr>
+      <p:sp>
+        <p:nvSpPr>
+          <p:cNvPr id="8" name="Rounded Rectangle 7"/>
+          <p:cNvSpPr/>
           <p:nvPr/>
-        </p:nvGraphicFramePr>
-        <p:xfrm>
-          <a:off x="548640" y="4160520"/>
-          <a:ext cx="11094415" cy="2103120"/>
-        </p:xfrm>
-        <a:graphic>
-          <a:graphicData uri="http://schemas.openxmlformats.org/drawingml/2006/table">
-            <a:tbl>
-              <a:tblPr firstRow="1" bandRow="1">
-                <a:tableStyleId>{5C22544A-7EE6-4342-B048-85BDC9FD1C3A}</a:tableStyleId>
-              </a:tblPr>
-              <a:tblGrid>
-                <a:gridCol w="2194560"/>
-                <a:gridCol w="1280160"/>
-                <a:gridCol w="1280160"/>
-                <a:gridCol w="1188720"/>
-                <a:gridCol w="1005840"/>
-                <a:gridCol w="1554480"/>
-                <a:gridCol w="1463040"/>
-                <a:gridCol w="1127455"/>
-              </a:tblGrid>
-              <a:tr h="420624">
-                <a:tc>
-                  <a:txBody>
-                    <a:bodyPr/>
-                    <a:lstStyle/>
-                    <a:p>
-                      <a:pPr algn="l">
-                        <a:defRPr sz="1100" b="1">
-                          <a:solidFill>
-                            <a:srgbClr val="FFFFFF"/>
-                          </a:solidFill>
-                          <a:latin typeface="Calibri"/>
-                        </a:defRPr>
-                      </a:pPr>
-                      <a:r>
-                        <a:t>Model Architecture</a:t>
-                      </a:r>
-                    </a:p>
-                  </a:txBody>
-                  <a:tcPr anchor="ctr">
-                    <a:solidFill>
-                      <a:srgbClr val="0F2942"/>
-                    </a:solidFill>
-                  </a:tcPr>
-                </a:tc>
-                <a:tc>
-                  <a:txBody>
-                    <a:bodyPr/>
-                    <a:lstStyle/>
-                    <a:p>
-                      <a:pPr algn="ctr">
-                        <a:defRPr sz="1100" b="1">
-                          <a:solidFill>
-                            <a:srgbClr val="FFFFFF"/>
-                          </a:solidFill>
-                          <a:latin typeface="Calibri"/>
-                        </a:defRPr>
-                      </a:pPr>
-                      <a:r>
-                        <a:t>WMAE (USD) ↓</a:t>
-                      </a:r>
-                    </a:p>
-                  </a:txBody>
-                  <a:tcPr anchor="ctr">
-                    <a:solidFill>
-                      <a:srgbClr val="0F2942"/>
-                    </a:solidFill>
-                  </a:tcPr>
-                </a:tc>
-                <a:tc>
-                  <a:txBody>
-                    <a:bodyPr/>
-                    <a:lstStyle/>
-                    <a:p>
-                      <a:pPr algn="ctr">
-                        <a:defRPr sz="1100" b="1">
-                          <a:solidFill>
-                            <a:srgbClr val="FFFFFF"/>
-                          </a:solidFill>
-                          <a:latin typeface="Calibri"/>
-                        </a:defRPr>
-                      </a:pPr>
-                      <a:r>
-                        <a:t>RMSE (USD) ↓</a:t>
-                      </a:r>
-                    </a:p>
-                  </a:txBody>
-                  <a:tcPr anchor="ctr">
-                    <a:solidFill>
-                      <a:srgbClr val="0F2942"/>
-                    </a:solidFill>
-                  </a:tcPr>
-                </a:tc>
-                <a:tc>
-                  <a:txBody>
-                    <a:bodyPr/>
-                    <a:lstStyle/>
-                    <a:p>
-                      <a:pPr algn="ctr">
-                        <a:defRPr sz="1100" b="1">
-                          <a:solidFill>
-                            <a:srgbClr val="FFFFFF"/>
-                          </a:solidFill>
-                          <a:latin typeface="Calibri"/>
-                        </a:defRPr>
-                      </a:pPr>
-                      <a:r>
-                        <a:t>MAE (USD) ↓</a:t>
-                      </a:r>
-                    </a:p>
-                  </a:txBody>
-                  <a:tcPr anchor="ctr">
-                    <a:solidFill>
-                      <a:srgbClr val="0F2942"/>
-                    </a:solidFill>
-                  </a:tcPr>
-                </a:tc>
-                <a:tc>
-                  <a:txBody>
-                    <a:bodyPr/>
-                    <a:lstStyle/>
-                    <a:p>
-                      <a:pPr algn="ctr">
-                        <a:defRPr sz="1100" b="1">
-                          <a:solidFill>
-                            <a:srgbClr val="FFFFFF"/>
-                          </a:solidFill>
-                          <a:latin typeface="Calibri"/>
-                        </a:defRPr>
-                      </a:pPr>
-                      <a:r>
-                        <a:t>R² Score ↑</a:t>
-                      </a:r>
-                    </a:p>
-                  </a:txBody>
-                  <a:tcPr anchor="ctr">
-                    <a:solidFill>
-                      <a:srgbClr val="0F2942"/>
-                    </a:solidFill>
-                  </a:tcPr>
-                </a:tc>
-                <a:tc>
-                  <a:txBody>
-                    <a:bodyPr/>
-                    <a:lstStyle/>
-                    <a:p>
-                      <a:pPr algn="ctr">
-                        <a:defRPr sz="1100" b="1">
-                          <a:solidFill>
-                            <a:srgbClr val="FFFFFF"/>
-                          </a:solidFill>
-                          <a:latin typeface="Calibri"/>
-                        </a:defRPr>
-                      </a:pPr>
-                      <a:r>
-                        <a:t>Holiday MAE (w=5) ↓</a:t>
-                      </a:r>
-                    </a:p>
-                  </a:txBody>
-                  <a:tcPr anchor="ctr">
-                    <a:solidFill>
-                      <a:srgbClr val="0F2942"/>
-                    </a:solidFill>
-                  </a:tcPr>
-                </a:tc>
-                <a:tc>
-                  <a:txBody>
-                    <a:bodyPr/>
-                    <a:lstStyle/>
-                    <a:p>
-                      <a:pPr algn="ctr">
-                        <a:defRPr sz="1100" b="1">
-                          <a:solidFill>
-                            <a:srgbClr val="FFFFFF"/>
-                          </a:solidFill>
-                          <a:latin typeface="Calibri"/>
-                        </a:defRPr>
-                      </a:pPr>
-                      <a:r>
-                        <a:t>Regular MAE (w=1) ↓</a:t>
-                      </a:r>
-                    </a:p>
-                  </a:txBody>
-                  <a:tcPr anchor="ctr">
-                    <a:solidFill>
-                      <a:srgbClr val="0F2942"/>
-                    </a:solidFill>
-                  </a:tcPr>
-                </a:tc>
-                <a:tc>
-                  <a:txBody>
-                    <a:bodyPr/>
-                    <a:lstStyle/>
-                    <a:p>
-                      <a:pPr algn="ctr">
-                        <a:defRPr sz="1100" b="1">
-                          <a:solidFill>
-                            <a:srgbClr val="FFFFFF"/>
-                          </a:solidFill>
-                          <a:latin typeface="Calibri"/>
-                        </a:defRPr>
-                      </a:pPr>
-                      <a:r>
-                        <a:t>Train Time</a:t>
-                      </a:r>
-                    </a:p>
-                  </a:txBody>
-                  <a:tcPr anchor="ctr">
-                    <a:solidFill>
-                      <a:srgbClr val="0F2942"/>
-                    </a:solidFill>
-                  </a:tcPr>
-                </a:tc>
-              </a:tr>
-              <a:tr h="420624">
-                <a:tc>
-                  <a:txBody>
-                    <a:bodyPr/>
-                    <a:lstStyle/>
-                    <a:p>
-                      <a:pPr algn="l">
-                        <a:defRPr sz="1050" b="1">
-                          <a:solidFill>
-                            <a:srgbClr val="1E293B"/>
-                          </a:solidFill>
-                          <a:latin typeface="Calibri"/>
-                        </a:defRPr>
-                      </a:pPr>
-                      <a:r>
-                        <a:t>Baseline (Ridge Regression)</a:t>
-                      </a:r>
-                    </a:p>
-                  </a:txBody>
-                  <a:tcPr anchor="ctr">
-                    <a:solidFill>
-                      <a:srgbClr val="F8FAFC"/>
-                    </a:solidFill>
-                  </a:tcPr>
-                </a:tc>
-                <a:tc>
-                  <a:txBody>
-                    <a:bodyPr/>
-                    <a:lstStyle/>
-                    <a:p>
-                      <a:pPr algn="ctr">
-                        <a:defRPr sz="1050" b="0">
-                          <a:solidFill>
-                            <a:srgbClr val="1E293B"/>
-                          </a:solidFill>
-                          <a:latin typeface="Calibri"/>
-                        </a:defRPr>
-                      </a:pPr>
-                      <a:r>
-                        <a:t>$4,393.17</a:t>
-                      </a:r>
-                    </a:p>
-                  </a:txBody>
-                  <a:tcPr anchor="ctr">
-                    <a:solidFill>
-                      <a:srgbClr val="F8FAFC"/>
-                    </a:solidFill>
-                  </a:tcPr>
-                </a:tc>
-                <a:tc>
-                  <a:txBody>
-                    <a:bodyPr/>
-                    <a:lstStyle/>
-                    <a:p>
-                      <a:pPr algn="ctr">
-                        <a:defRPr sz="1050" b="0">
-                          <a:solidFill>
-                            <a:srgbClr val="1E293B"/>
-                          </a:solidFill>
-                          <a:latin typeface="Calibri"/>
-                        </a:defRPr>
-                      </a:pPr>
-                      <a:r>
-                        <a:t>$6,616.57</a:t>
-                      </a:r>
-                    </a:p>
-                  </a:txBody>
-                  <a:tcPr anchor="ctr">
-                    <a:solidFill>
-                      <a:srgbClr val="F8FAFC"/>
-                    </a:solidFill>
-                  </a:tcPr>
-                </a:tc>
-                <a:tc>
-                  <a:txBody>
-                    <a:bodyPr/>
-                    <a:lstStyle/>
-                    <a:p>
-                      <a:pPr algn="ctr">
-                        <a:defRPr sz="1050" b="0">
-                          <a:solidFill>
-                            <a:srgbClr val="1E293B"/>
-                          </a:solidFill>
-                          <a:latin typeface="Calibri"/>
-                        </a:defRPr>
-                      </a:pPr>
-                      <a:r>
-                        <a:t>$2,514.98</a:t>
-                      </a:r>
-                    </a:p>
-                  </a:txBody>
-                  <a:tcPr anchor="ctr">
-                    <a:solidFill>
-                      <a:srgbClr val="F8FAFC"/>
-                    </a:solidFill>
-                  </a:tcPr>
-                </a:tc>
-                <a:tc>
-                  <a:txBody>
-                    <a:bodyPr/>
-                    <a:lstStyle/>
-                    <a:p>
-                      <a:pPr algn="ctr">
-                        <a:defRPr sz="1050" b="0">
-                          <a:solidFill>
-                            <a:srgbClr val="1E293B"/>
-                          </a:solidFill>
-                          <a:latin typeface="Calibri"/>
-                        </a:defRPr>
-                      </a:pPr>
-                      <a:r>
-                        <a:t>0.9183</a:t>
-                      </a:r>
-                    </a:p>
-                  </a:txBody>
-                  <a:tcPr anchor="ctr">
-                    <a:solidFill>
-                      <a:srgbClr val="F8FAFC"/>
-                    </a:solidFill>
-                  </a:tcPr>
-                </a:tc>
-                <a:tc>
-                  <a:txBody>
-                    <a:bodyPr/>
-                    <a:lstStyle/>
-                    <a:p>
-                      <a:pPr algn="ctr">
-                        <a:defRPr sz="1050" b="0">
-                          <a:solidFill>
-                            <a:srgbClr val="1E293B"/>
-                          </a:solidFill>
-                          <a:latin typeface="Calibri"/>
-                        </a:defRPr>
-                      </a:pPr>
-                      <a:r>
-                        <a:t>$10,108.52</a:t>
-                      </a:r>
-                    </a:p>
-                  </a:txBody>
-                  <a:tcPr anchor="ctr">
-                    <a:solidFill>
-                      <a:srgbClr val="F8FAFC"/>
-                    </a:solidFill>
-                  </a:tcPr>
-                </a:tc>
-                <a:tc>
-                  <a:txBody>
-                    <a:bodyPr/>
-                    <a:lstStyle/>
-                    <a:p>
-                      <a:pPr algn="ctr">
-                        <a:defRPr sz="1050" b="0">
-                          <a:solidFill>
-                            <a:srgbClr val="1E293B"/>
-                          </a:solidFill>
-                          <a:latin typeface="Calibri"/>
-                        </a:defRPr>
-                      </a:pPr>
-                      <a:r>
-                        <a:t>$1,835.29</a:t>
-                      </a:r>
-                    </a:p>
-                  </a:txBody>
-                  <a:tcPr anchor="ctr">
-                    <a:solidFill>
-                      <a:srgbClr val="F8FAFC"/>
-                    </a:solidFill>
-                  </a:tcPr>
-                </a:tc>
-                <a:tc>
-                  <a:txBody>
-                    <a:bodyPr/>
-                    <a:lstStyle/>
-                    <a:p>
-                      <a:pPr algn="ctr">
-                        <a:defRPr sz="1050" b="0">
-                          <a:solidFill>
-                            <a:srgbClr val="1E293B"/>
-                          </a:solidFill>
-                          <a:latin typeface="Calibri"/>
-                        </a:defRPr>
-                      </a:pPr>
-                      <a:r>
-                        <a:t>0.20 s</a:t>
-                      </a:r>
-                    </a:p>
-                  </a:txBody>
-                  <a:tcPr anchor="ctr">
-                    <a:solidFill>
-                      <a:srgbClr val="F8FAFC"/>
-                    </a:solidFill>
-                  </a:tcPr>
-                </a:tc>
-              </a:tr>
-              <a:tr h="420624">
-                <a:tc>
-                  <a:txBody>
-                    <a:bodyPr/>
-                    <a:lstStyle/>
-                    <a:p>
-                      <a:pPr algn="l">
-                        <a:defRPr sz="1050" b="1">
-                          <a:solidFill>
-                            <a:srgbClr val="1E293B"/>
-                          </a:solidFill>
-                          <a:latin typeface="Calibri"/>
-                        </a:defRPr>
-                      </a:pPr>
-                      <a:r>
-                        <a:t>Random Forest Regressor</a:t>
-                      </a:r>
-                    </a:p>
-                  </a:txBody>
-                  <a:tcPr anchor="ctr">
-                    <a:solidFill>
-                      <a:srgbClr val="FFFFFF"/>
-                    </a:solidFill>
-                  </a:tcPr>
-                </a:tc>
-                <a:tc>
-                  <a:txBody>
-                    <a:bodyPr/>
-                    <a:lstStyle/>
-                    <a:p>
-                      <a:pPr algn="ctr">
-                        <a:defRPr sz="1050" b="0">
-                          <a:solidFill>
-                            <a:srgbClr val="1E293B"/>
-                          </a:solidFill>
-                          <a:latin typeface="Calibri"/>
-                        </a:defRPr>
-                      </a:pPr>
-                      <a:r>
-                        <a:t>$1,791.54</a:t>
-                      </a:r>
-                    </a:p>
-                  </a:txBody>
-                  <a:tcPr anchor="ctr">
-                    <a:solidFill>
-                      <a:srgbClr val="FFFFFF"/>
-                    </a:solidFill>
-                  </a:tcPr>
-                </a:tc>
-                <a:tc>
-                  <a:txBody>
-                    <a:bodyPr/>
-                    <a:lstStyle/>
-                    <a:p>
-                      <a:pPr algn="ctr">
-                        <a:defRPr sz="1050" b="0">
-                          <a:solidFill>
-                            <a:srgbClr val="1E293B"/>
-                          </a:solidFill>
-                          <a:latin typeface="Calibri"/>
-                        </a:defRPr>
-                      </a:pPr>
-                      <a:r>
-                        <a:t>$4,413.86</a:t>
-                      </a:r>
-                    </a:p>
-                  </a:txBody>
-                  <a:tcPr anchor="ctr">
-                    <a:solidFill>
-                      <a:srgbClr val="FFFFFF"/>
-                    </a:solidFill>
-                  </a:tcPr>
-                </a:tc>
-                <a:tc>
-                  <a:txBody>
-                    <a:bodyPr/>
-                    <a:lstStyle/>
-                    <a:p>
-                      <a:pPr algn="ctr">
-                        <a:defRPr sz="1050" b="0">
-                          <a:solidFill>
-                            <a:srgbClr val="1E293B"/>
-                          </a:solidFill>
-                          <a:latin typeface="Calibri"/>
-                        </a:defRPr>
-                      </a:pPr>
-                      <a:r>
-                        <a:t>$1,520.75</a:t>
-                      </a:r>
-                    </a:p>
-                  </a:txBody>
-                  <a:tcPr anchor="ctr">
-                    <a:solidFill>
-                      <a:srgbClr val="FFFFFF"/>
-                    </a:solidFill>
-                  </a:tcPr>
-                </a:tc>
-                <a:tc>
-                  <a:txBody>
-                    <a:bodyPr/>
-                    <a:lstStyle/>
-                    <a:p>
-                      <a:pPr algn="ctr">
-                        <a:defRPr sz="1050" b="0">
-                          <a:solidFill>
-                            <a:srgbClr val="1E293B"/>
-                          </a:solidFill>
-                          <a:latin typeface="Calibri"/>
-                        </a:defRPr>
-                      </a:pPr>
-                      <a:r>
-                        <a:t>0.9637</a:t>
-                      </a:r>
-                    </a:p>
-                  </a:txBody>
-                  <a:tcPr anchor="ctr">
-                    <a:solidFill>
-                      <a:srgbClr val="FFFFFF"/>
-                    </a:solidFill>
-                  </a:tcPr>
-                </a:tc>
-                <a:tc>
-                  <a:txBody>
-                    <a:bodyPr/>
-                    <a:lstStyle/>
-                    <a:p>
-                      <a:pPr algn="ctr">
-                        <a:defRPr sz="1050" b="0">
-                          <a:solidFill>
-                            <a:srgbClr val="1E293B"/>
-                          </a:solidFill>
-                          <a:latin typeface="Calibri"/>
-                        </a:defRPr>
-                      </a:pPr>
-                      <a:r>
-                        <a:t>$2,615.57</a:t>
-                      </a:r>
-                    </a:p>
-                  </a:txBody>
-                  <a:tcPr anchor="ctr">
-                    <a:solidFill>
-                      <a:srgbClr val="FFFFFF"/>
-                    </a:solidFill>
-                  </a:tcPr>
-                </a:tc>
-                <a:tc>
-                  <a:txBody>
-                    <a:bodyPr/>
-                    <a:lstStyle/>
-                    <a:p>
-                      <a:pPr algn="ctr">
-                        <a:defRPr sz="1050" b="0">
-                          <a:solidFill>
-                            <a:srgbClr val="1E293B"/>
-                          </a:solidFill>
-                          <a:latin typeface="Calibri"/>
-                        </a:defRPr>
-                      </a:pPr>
-                      <a:r>
-                        <a:t>$1,422.75</a:t>
-                      </a:r>
-                    </a:p>
-                  </a:txBody>
-                  <a:tcPr anchor="ctr">
-                    <a:solidFill>
-                      <a:srgbClr val="FFFFFF"/>
-                    </a:solidFill>
-                  </a:tcPr>
-                </a:tc>
-                <a:tc>
-                  <a:txBody>
-                    <a:bodyPr/>
-                    <a:lstStyle/>
-                    <a:p>
-                      <a:pPr algn="ctr">
-                        <a:defRPr sz="1050" b="0">
-                          <a:solidFill>
-                            <a:srgbClr val="1E293B"/>
-                          </a:solidFill>
-                          <a:latin typeface="Calibri"/>
-                        </a:defRPr>
-                      </a:pPr>
-                      <a:r>
-                        <a:t>42.88 s</a:t>
-                      </a:r>
-                    </a:p>
-                  </a:txBody>
-                  <a:tcPr anchor="ctr">
-                    <a:solidFill>
-                      <a:srgbClr val="FFFFFF"/>
-                    </a:solidFill>
-                  </a:tcPr>
-                </a:tc>
-              </a:tr>
-              <a:tr h="420624">
-                <a:tc>
-                  <a:txBody>
-                    <a:bodyPr/>
-                    <a:lstStyle/>
-                    <a:p>
-                      <a:pPr algn="l">
-                        <a:defRPr sz="1050" b="1">
-                          <a:solidFill>
-                            <a:srgbClr val="1E293B"/>
-                          </a:solidFill>
-                          <a:latin typeface="Calibri"/>
-                        </a:defRPr>
-                      </a:pPr>
-                      <a:r>
-                        <a:t>XGBoost Regressor</a:t>
-                      </a:r>
-                    </a:p>
-                  </a:txBody>
-                  <a:tcPr anchor="ctr">
-                    <a:solidFill>
-                      <a:srgbClr val="F8FAFC"/>
-                    </a:solidFill>
-                  </a:tcPr>
-                </a:tc>
-                <a:tc>
-                  <a:txBody>
-                    <a:bodyPr/>
-                    <a:lstStyle/>
-                    <a:p>
-                      <a:pPr algn="ctr">
-                        <a:defRPr sz="1050" b="0">
-                          <a:solidFill>
-                            <a:srgbClr val="1E293B"/>
-                          </a:solidFill>
-                          <a:latin typeface="Calibri"/>
-                        </a:defRPr>
-                      </a:pPr>
-                      <a:r>
-                        <a:t>$1,837.57</a:t>
-                      </a:r>
-                    </a:p>
-                  </a:txBody>
-                  <a:tcPr anchor="ctr">
-                    <a:solidFill>
-                      <a:srgbClr val="F8FAFC"/>
-                    </a:solidFill>
-                  </a:tcPr>
-                </a:tc>
-                <a:tc>
-                  <a:txBody>
-                    <a:bodyPr/>
-                    <a:lstStyle/>
-                    <a:p>
-                      <a:pPr algn="ctr">
-                        <a:defRPr sz="1050" b="0">
-                          <a:solidFill>
-                            <a:srgbClr val="1E293B"/>
-                          </a:solidFill>
-                          <a:latin typeface="Calibri"/>
-                        </a:defRPr>
-                      </a:pPr>
-                      <a:r>
-                        <a:t>$4,306.19</a:t>
-                      </a:r>
-                    </a:p>
-                  </a:txBody>
-                  <a:tcPr anchor="ctr">
-                    <a:solidFill>
-                      <a:srgbClr val="F8FAFC"/>
-                    </a:solidFill>
-                  </a:tcPr>
-                </a:tc>
-                <a:tc>
-                  <a:txBody>
-                    <a:bodyPr/>
-                    <a:lstStyle/>
-                    <a:p>
-                      <a:pPr algn="ctr">
-                        <a:defRPr sz="1050" b="0">
-                          <a:solidFill>
-                            <a:srgbClr val="1E293B"/>
-                          </a:solidFill>
-                          <a:latin typeface="Calibri"/>
-                        </a:defRPr>
-                      </a:pPr>
-                      <a:r>
-                        <a:t>$1,523.89</a:t>
-                      </a:r>
-                    </a:p>
-                  </a:txBody>
-                  <a:tcPr anchor="ctr">
-                    <a:solidFill>
-                      <a:srgbClr val="F8FAFC"/>
-                    </a:solidFill>
-                  </a:tcPr>
-                </a:tc>
-                <a:tc>
-                  <a:txBody>
-                    <a:bodyPr/>
-                    <a:lstStyle/>
-                    <a:p>
-                      <a:pPr algn="ctr">
-                        <a:defRPr sz="1050" b="0">
-                          <a:solidFill>
-                            <a:srgbClr val="1E293B"/>
-                          </a:solidFill>
-                          <a:latin typeface="Calibri"/>
-                        </a:defRPr>
-                      </a:pPr>
-                      <a:r>
-                        <a:t>0.9654</a:t>
-                      </a:r>
-                    </a:p>
-                  </a:txBody>
-                  <a:tcPr anchor="ctr">
-                    <a:solidFill>
-                      <a:srgbClr val="F8FAFC"/>
-                    </a:solidFill>
-                  </a:tcPr>
-                </a:tc>
-                <a:tc>
-                  <a:txBody>
-                    <a:bodyPr/>
-                    <a:lstStyle/>
-                    <a:p>
-                      <a:pPr algn="ctr">
-                        <a:defRPr sz="1050" b="0">
-                          <a:solidFill>
-                            <a:srgbClr val="1E293B"/>
-                          </a:solidFill>
-                          <a:latin typeface="Calibri"/>
-                        </a:defRPr>
-                      </a:pPr>
-                      <a:r>
-                        <a:t>$2,792.11</a:t>
-                      </a:r>
-                    </a:p>
-                  </a:txBody>
-                  <a:tcPr anchor="ctr">
-                    <a:solidFill>
-                      <a:srgbClr val="F8FAFC"/>
-                    </a:solidFill>
-                  </a:tcPr>
-                </a:tc>
-                <a:tc>
-                  <a:txBody>
-                    <a:bodyPr/>
-                    <a:lstStyle/>
-                    <a:p>
-                      <a:pPr algn="ctr">
-                        <a:defRPr sz="1050" b="0">
-                          <a:solidFill>
-                            <a:srgbClr val="1E293B"/>
-                          </a:solidFill>
-                          <a:latin typeface="Calibri"/>
-                        </a:defRPr>
-                      </a:pPr>
-                      <a:r>
-                        <a:t>$1,410.37</a:t>
-                      </a:r>
-                    </a:p>
-                  </a:txBody>
-                  <a:tcPr anchor="ctr">
-                    <a:solidFill>
-                      <a:srgbClr val="F8FAFC"/>
-                    </a:solidFill>
-                  </a:tcPr>
-                </a:tc>
-                <a:tc>
-                  <a:txBody>
-                    <a:bodyPr/>
-                    <a:lstStyle/>
-                    <a:p>
-                      <a:pPr algn="ctr">
-                        <a:defRPr sz="1050" b="0">
-                          <a:solidFill>
-                            <a:srgbClr val="1E293B"/>
-                          </a:solidFill>
-                          <a:latin typeface="Calibri"/>
-                        </a:defRPr>
-                      </a:pPr>
-                      <a:r>
-                        <a:t>6.31 s</a:t>
-                      </a:r>
-                    </a:p>
-                  </a:txBody>
-                  <a:tcPr anchor="ctr">
-                    <a:solidFill>
-                      <a:srgbClr val="F8FAFC"/>
-                    </a:solidFill>
-                  </a:tcPr>
-                </a:tc>
-              </a:tr>
-              <a:tr h="420624">
-                <a:tc>
-                  <a:txBody>
-                    <a:bodyPr/>
-                    <a:lstStyle/>
-                    <a:p>
-                      <a:pPr algn="l">
-                        <a:defRPr sz="1050" b="1">
-                          <a:solidFill>
-                            <a:srgbClr val="0D9488"/>
-                          </a:solidFill>
-                          <a:latin typeface="Calibri"/>
-                        </a:defRPr>
-                      </a:pPr>
-                      <a:r>
-                        <a:t>LightGBM Regressor (Winner)</a:t>
-                      </a:r>
-                    </a:p>
-                  </a:txBody>
-                  <a:tcPr anchor="ctr">
-                    <a:solidFill>
-                      <a:srgbClr val="ECFDF5"/>
-                    </a:solidFill>
-                  </a:tcPr>
-                </a:tc>
-                <a:tc>
-                  <a:txBody>
-                    <a:bodyPr/>
-                    <a:lstStyle/>
-                    <a:p>
-                      <a:pPr algn="ctr">
-                        <a:defRPr sz="1050" b="1">
-                          <a:solidFill>
-                            <a:srgbClr val="0D9488"/>
-                          </a:solidFill>
-                          <a:latin typeface="Calibri"/>
-                        </a:defRPr>
-                      </a:pPr>
-                      <a:r>
-                        <a:t>$1,758.94</a:t>
-                      </a:r>
-                    </a:p>
-                  </a:txBody>
-                  <a:tcPr anchor="ctr">
-                    <a:solidFill>
-                      <a:srgbClr val="ECFDF5"/>
-                    </a:solidFill>
-                  </a:tcPr>
-                </a:tc>
-                <a:tc>
-                  <a:txBody>
-                    <a:bodyPr/>
-                    <a:lstStyle/>
-                    <a:p>
-                      <a:pPr algn="ctr">
-                        <a:defRPr sz="1050" b="1">
-                          <a:solidFill>
-                            <a:srgbClr val="0D9488"/>
-                          </a:solidFill>
-                          <a:latin typeface="Calibri"/>
-                        </a:defRPr>
-                      </a:pPr>
-                      <a:r>
-                        <a:t>$3,837.62</a:t>
-                      </a:r>
-                    </a:p>
-                  </a:txBody>
-                  <a:tcPr anchor="ctr">
-                    <a:solidFill>
-                      <a:srgbClr val="ECFDF5"/>
-                    </a:solidFill>
-                  </a:tcPr>
-                </a:tc>
-                <a:tc>
-                  <a:txBody>
-                    <a:bodyPr/>
-                    <a:lstStyle/>
-                    <a:p>
-                      <a:pPr algn="ctr">
-                        <a:defRPr sz="1050" b="1">
-                          <a:solidFill>
-                            <a:srgbClr val="0D9488"/>
-                          </a:solidFill>
-                          <a:latin typeface="Calibri"/>
-                        </a:defRPr>
-                      </a:pPr>
-                      <a:r>
-                        <a:t>$1,541.31</a:t>
-                      </a:r>
-                    </a:p>
-                  </a:txBody>
-                  <a:tcPr anchor="ctr">
-                    <a:solidFill>
-                      <a:srgbClr val="ECFDF5"/>
-                    </a:solidFill>
-                  </a:tcPr>
-                </a:tc>
-                <a:tc>
-                  <a:txBody>
-                    <a:bodyPr/>
-                    <a:lstStyle/>
-                    <a:p>
-                      <a:pPr algn="ctr">
-                        <a:defRPr sz="1050" b="1">
-                          <a:solidFill>
-                            <a:srgbClr val="0D9488"/>
-                          </a:solidFill>
-                          <a:latin typeface="Calibri"/>
-                        </a:defRPr>
-                      </a:pPr>
-                      <a:r>
-                        <a:t>0.9725</a:t>
-                      </a:r>
-                    </a:p>
-                  </a:txBody>
-                  <a:tcPr anchor="ctr">
-                    <a:solidFill>
-                      <a:srgbClr val="ECFDF5"/>
-                    </a:solidFill>
-                  </a:tcPr>
-                </a:tc>
-                <a:tc>
-                  <a:txBody>
-                    <a:bodyPr/>
-                    <a:lstStyle/>
-                    <a:p>
-                      <a:pPr algn="ctr">
-                        <a:defRPr sz="1050" b="1">
-                          <a:solidFill>
-                            <a:srgbClr val="0D9488"/>
-                          </a:solidFill>
-                          <a:latin typeface="Calibri"/>
-                        </a:defRPr>
-                      </a:pPr>
-                      <a:r>
-                        <a:t>$2,421.19</a:t>
-                      </a:r>
-                    </a:p>
-                  </a:txBody>
-                  <a:tcPr anchor="ctr">
-                    <a:solidFill>
-                      <a:srgbClr val="ECFDF5"/>
-                    </a:solidFill>
-                  </a:tcPr>
-                </a:tc>
-                <a:tc>
-                  <a:txBody>
-                    <a:bodyPr/>
-                    <a:lstStyle/>
-                    <a:p>
-                      <a:pPr algn="ctr">
-                        <a:defRPr sz="1050" b="1">
-                          <a:solidFill>
-                            <a:srgbClr val="0D9488"/>
-                          </a:solidFill>
-                          <a:latin typeface="Calibri"/>
-                        </a:defRPr>
-                      </a:pPr>
-                      <a:r>
-                        <a:t>$1,462.55</a:t>
-                      </a:r>
-                    </a:p>
-                  </a:txBody>
-                  <a:tcPr anchor="ctr">
-                    <a:solidFill>
-                      <a:srgbClr val="ECFDF5"/>
-                    </a:solidFill>
-                  </a:tcPr>
-                </a:tc>
-                <a:tc>
-                  <a:txBody>
-                    <a:bodyPr/>
-                    <a:lstStyle/>
-                    <a:p>
-                      <a:pPr algn="ctr">
-                        <a:defRPr sz="1050" b="1">
-                          <a:solidFill>
-                            <a:srgbClr val="0D9488"/>
-                          </a:solidFill>
-                          <a:latin typeface="Calibri"/>
-                        </a:defRPr>
-                      </a:pPr>
-                      <a:r>
-                        <a:t>4.91 s</a:t>
-                      </a:r>
-                    </a:p>
-                  </a:txBody>
-                  <a:tcPr anchor="ctr">
-                    <a:solidFill>
-                      <a:srgbClr val="ECFDF5"/>
-                    </a:solidFill>
-                  </a:tcPr>
-                </a:tc>
-              </a:tr>
-            </a:tbl>
-          </a:graphicData>
-        </a:graphic>
-      </p:graphicFrame>
+        </p:nvSpPr>
+        <p:spPr>
+          <a:xfrm>
+            <a:off x="7955279" y="1234440"/>
+            <a:ext cx="3657600" cy="2468880"/>
+          </a:xfrm>
+          <a:prstGeom prst="roundRect">
+            <a:avLst>
+              <a:gd name="adj" fmla="val 4000"/>
+            </a:avLst>
+          </a:prstGeom>
+          <a:solidFill>
+            <a:srgbClr val="F8FAFC"/>
+          </a:solidFill>
+          <a:ln w="12700">
+            <a:solidFill>
+              <a:srgbClr val="E2E8F0"/>
+            </a:solidFill>
+          </a:ln>
+        </p:spPr>
+        <p:style>
+          <a:lnRef idx="1">
+            <a:schemeClr val="accent1"/>
+          </a:lnRef>
+          <a:fillRef idx="3">
+            <a:schemeClr val="accent1"/>
+          </a:fillRef>
+          <a:effectRef idx="2">
+            <a:schemeClr val="accent1"/>
+          </a:effectRef>
+          <a:fontRef idx="minor">
+            <a:schemeClr val="lt1"/>
+          </a:fontRef>
+        </p:style>
+        <p:txBody>
+          <a:bodyPr rtlCol="0" anchor="ctr"/>
+          <a:lstStyle/>
+          <a:p>
+            <a:pPr algn="ctr"/>
+          </a:p>
+        </p:txBody>
+      </p:sp>
+      <p:sp>
+        <p:nvSpPr>
+          <p:cNvPr id="9" name="Rounded Rectangle 8"/>
+          <p:cNvSpPr/>
+          <p:nvPr/>
+        </p:nvSpPr>
+        <p:spPr>
+          <a:xfrm>
+            <a:off x="7955279" y="1234440"/>
+            <a:ext cx="3657600" cy="402336"/>
+          </a:xfrm>
+          <a:prstGeom prst="roundRect">
+            <a:avLst>
+              <a:gd name="adj" fmla="val 8000"/>
+            </a:avLst>
+          </a:prstGeom>
+          <a:solidFill>
+            <a:srgbClr val="10B981"/>
+          </a:solidFill>
+          <a:ln>
+            <a:noFill/>
+          </a:ln>
+        </p:spPr>
+        <p:style>
+          <a:lnRef idx="1">
+            <a:schemeClr val="accent1"/>
+          </a:lnRef>
+          <a:fillRef idx="3">
+            <a:schemeClr val="accent1"/>
+          </a:fillRef>
+          <a:effectRef idx="2">
+            <a:schemeClr val="accent1"/>
+          </a:effectRef>
+          <a:fontRef idx="minor">
+            <a:schemeClr val="lt1"/>
+          </a:fontRef>
+        </p:style>
+        <p:txBody>
+          <a:bodyPr rtlCol="0" anchor="ctr"/>
+          <a:lstStyle/>
+          <a:p>
+            <a:pPr algn="ctr"/>
+          </a:p>
+        </p:txBody>
+      </p:sp>
+      <p:sp>
+        <p:nvSpPr>
+          <p:cNvPr id="10" name="TextBox 9"/>
+          <p:cNvSpPr txBox="1"/>
+          <p:nvPr/>
+        </p:nvSpPr>
+        <p:spPr>
+          <a:xfrm>
+            <a:off x="8092440" y="1280160"/>
+            <a:ext cx="3383280" cy="320040"/>
+          </a:xfrm>
+          <a:prstGeom prst="rect">
+            <a:avLst/>
+          </a:prstGeom>
+          <a:noFill/>
+        </p:spPr>
+        <p:txBody>
+          <a:bodyPr wrap="none">
+            <a:spAutoFit/>
+          </a:bodyPr>
+          <a:lstStyle/>
+          <a:p>
+            <a:pPr>
+              <a:defRPr sz="1300" b="1">
+                <a:solidFill>
+                  <a:srgbClr val="FFFFFF"/>
+                </a:solidFill>
+                <a:latin typeface="Calibri"/>
+              </a:defRPr>
+            </a:pPr>
+            <a:r>
+              <a:t>Performance Comparison</a:t>
+            </a:r>
+          </a:p>
+        </p:txBody>
+      </p:sp>
+      <p:sp>
+        <p:nvSpPr>
+          <p:cNvPr id="11" name="TextBox 10"/>
+          <p:cNvSpPr txBox="1"/>
+          <p:nvPr/>
+        </p:nvSpPr>
+        <p:spPr>
+          <a:xfrm>
+            <a:off x="8138159" y="1709928"/>
+            <a:ext cx="3291840" cy="1920240"/>
+          </a:xfrm>
+          <a:prstGeom prst="rect">
+            <a:avLst/>
+          </a:prstGeom>
+          <a:noFill/>
+        </p:spPr>
+        <p:txBody>
+          <a:bodyPr wrap="square">
+            <a:spAutoFit/>
+          </a:bodyPr>
+          <a:lstStyle/>
+          <a:p>
+            <a:pPr>
+              <a:spcAft>
+                <a:spcPts val="600"/>
+              </a:spcAft>
+              <a:defRPr sz="1200">
+                <a:solidFill>
+                  <a:srgbClr val="1E293B"/>
+                </a:solidFill>
+                <a:latin typeface="Calibri"/>
+              </a:defRPr>
+            </a:pPr>
+            <a:r>
+              <a:t>• Baseline (Ridge): WMAE $4,393 (Linear model overshoots heavily during holidays).</a:t>
+            </a:r>
+          </a:p>
+          <a:p>
+            <a:pPr>
+              <a:spcAft>
+                <a:spcPts val="600"/>
+              </a:spcAft>
+              <a:defRPr sz="1200">
+                <a:solidFill>
+                  <a:srgbClr val="1E293B"/>
+                </a:solidFill>
+                <a:latin typeface="Calibri"/>
+              </a:defRPr>
+            </a:pPr>
+            <a:r>
+              <a:t>• Random Forest: WMAE $1,792 (-59%).</a:t>
+            </a:r>
+          </a:p>
+          <a:p>
+            <a:pPr>
+              <a:spcAft>
+                <a:spcPts val="600"/>
+              </a:spcAft>
+              <a:defRPr sz="1200">
+                <a:solidFill>
+                  <a:srgbClr val="1E293B"/>
+                </a:solidFill>
+                <a:latin typeface="Calibri"/>
+              </a:defRPr>
+            </a:pPr>
+            <a:r>
+              <a:t>• XGBoost: WMAE $1,838 (-58%).</a:t>
+            </a:r>
+          </a:p>
+          <a:p>
+            <a:pPr>
+              <a:spcAft>
+                <a:spcPts val="600"/>
+              </a:spcAft>
+              <a:defRPr sz="1200">
+                <a:solidFill>
+                  <a:srgbClr val="1E293B"/>
+                </a:solidFill>
+                <a:latin typeface="Calibri"/>
+              </a:defRPr>
+            </a:pPr>
+            <a:r>
+              <a:t>• LightGBM: WMAE $1,759 (-60% Error Reduction, Winner!).</a:t>
+            </a:r>
+          </a:p>
+        </p:txBody>
+      </p:sp>
+      <p:sp>
+        <p:nvSpPr>
+          <p:cNvPr id="12" name="Rounded Rectangle 11"/>
+          <p:cNvSpPr/>
+          <p:nvPr/>
+        </p:nvSpPr>
+        <p:spPr>
+          <a:xfrm>
+            <a:off x="7955279" y="3886200"/>
+            <a:ext cx="3657600" cy="2423160"/>
+          </a:xfrm>
+          <a:prstGeom prst="roundRect">
+            <a:avLst>
+              <a:gd name="adj" fmla="val 4000"/>
+            </a:avLst>
+          </a:prstGeom>
+          <a:solidFill>
+            <a:srgbClr val="F8FAFC"/>
+          </a:solidFill>
+          <a:ln w="12700">
+            <a:solidFill>
+              <a:srgbClr val="E2E8F0"/>
+            </a:solidFill>
+          </a:ln>
+        </p:spPr>
+        <p:style>
+          <a:lnRef idx="1">
+            <a:schemeClr val="accent1"/>
+          </a:lnRef>
+          <a:fillRef idx="3">
+            <a:schemeClr val="accent1"/>
+          </a:fillRef>
+          <a:effectRef idx="2">
+            <a:schemeClr val="accent1"/>
+          </a:effectRef>
+          <a:fontRef idx="minor">
+            <a:schemeClr val="lt1"/>
+          </a:fontRef>
+        </p:style>
+        <p:txBody>
+          <a:bodyPr rtlCol="0" anchor="ctr"/>
+          <a:lstStyle/>
+          <a:p>
+            <a:pPr algn="ctr"/>
+          </a:p>
+        </p:txBody>
+      </p:sp>
+      <p:sp>
+        <p:nvSpPr>
+          <p:cNvPr id="13" name="Rounded Rectangle 12"/>
+          <p:cNvSpPr/>
+          <p:nvPr/>
+        </p:nvSpPr>
+        <p:spPr>
+          <a:xfrm>
+            <a:off x="7955279" y="3886200"/>
+            <a:ext cx="3657600" cy="402336"/>
+          </a:xfrm>
+          <a:prstGeom prst="roundRect">
+            <a:avLst>
+              <a:gd name="adj" fmla="val 8000"/>
+            </a:avLst>
+          </a:prstGeom>
+          <a:solidFill>
+            <a:srgbClr val="0F2942"/>
+          </a:solidFill>
+          <a:ln>
+            <a:noFill/>
+          </a:ln>
+        </p:spPr>
+        <p:style>
+          <a:lnRef idx="1">
+            <a:schemeClr val="accent1"/>
+          </a:lnRef>
+          <a:fillRef idx="3">
+            <a:schemeClr val="accent1"/>
+          </a:fillRef>
+          <a:effectRef idx="2">
+            <a:schemeClr val="accent1"/>
+          </a:effectRef>
+          <a:fontRef idx="minor">
+            <a:schemeClr val="lt1"/>
+          </a:fontRef>
+        </p:style>
+        <p:txBody>
+          <a:bodyPr rtlCol="0" anchor="ctr"/>
+          <a:lstStyle/>
+          <a:p>
+            <a:pPr algn="ctr"/>
+          </a:p>
+        </p:txBody>
+      </p:sp>
+      <p:sp>
+        <p:nvSpPr>
+          <p:cNvPr id="14" name="TextBox 13"/>
+          <p:cNvSpPr txBox="1"/>
+          <p:nvPr/>
+        </p:nvSpPr>
+        <p:spPr>
+          <a:xfrm>
+            <a:off x="8092440" y="3931920"/>
+            <a:ext cx="3383280" cy="320040"/>
+          </a:xfrm>
+          <a:prstGeom prst="rect">
+            <a:avLst/>
+          </a:prstGeom>
+          <a:noFill/>
+        </p:spPr>
+        <p:txBody>
+          <a:bodyPr wrap="none">
+            <a:spAutoFit/>
+          </a:bodyPr>
+          <a:lstStyle/>
+          <a:p>
+            <a:pPr>
+              <a:defRPr sz="1300" b="1">
+                <a:solidFill>
+                  <a:srgbClr val="FFFFFF"/>
+                </a:solidFill>
+                <a:latin typeface="Calibri"/>
+              </a:defRPr>
+            </a:pPr>
+            <a:r>
+              <a:t>Why LightGBM Won</a:t>
+            </a:r>
+          </a:p>
+        </p:txBody>
+      </p:sp>
+      <p:sp>
+        <p:nvSpPr>
+          <p:cNvPr id="15" name="TextBox 14"/>
+          <p:cNvSpPr txBox="1"/>
+          <p:nvPr/>
+        </p:nvSpPr>
+        <p:spPr>
+          <a:xfrm>
+            <a:off x="8138159" y="4361688"/>
+            <a:ext cx="3291840" cy="1874519"/>
+          </a:xfrm>
+          <a:prstGeom prst="rect">
+            <a:avLst/>
+          </a:prstGeom>
+          <a:noFill/>
+        </p:spPr>
+        <p:txBody>
+          <a:bodyPr wrap="square">
+            <a:spAutoFit/>
+          </a:bodyPr>
+          <a:lstStyle/>
+          <a:p>
+            <a:pPr>
+              <a:spcAft>
+                <a:spcPts val="600"/>
+              </a:spcAft>
+              <a:defRPr sz="1200">
+                <a:solidFill>
+                  <a:srgbClr val="1E293B"/>
+                </a:solidFill>
+                <a:latin typeface="Calibri"/>
+              </a:defRPr>
+            </a:pPr>
+            <a:r>
+              <a:t>• Holiday Error Slashed by 76%: Holiday MAE dropped from $10,108 down to $2,421.</a:t>
+            </a:r>
+          </a:p>
+          <a:p>
+            <a:pPr>
+              <a:spcAft>
+                <a:spcPts val="600"/>
+              </a:spcAft>
+              <a:defRPr sz="1200">
+                <a:solidFill>
+                  <a:srgbClr val="1E293B"/>
+                </a:solidFill>
+                <a:latin typeface="Calibri"/>
+              </a:defRPr>
+            </a:pPr>
+            <a:r>
+              <a:t>• Superior Fit: R² = 0.9725 (explains 97.25% of variance across 81 departments).</a:t>
+            </a:r>
+          </a:p>
+          <a:p>
+            <a:pPr>
+              <a:spcAft>
+                <a:spcPts val="600"/>
+              </a:spcAft>
+              <a:defRPr sz="1200">
+                <a:solidFill>
+                  <a:srgbClr val="1E293B"/>
+                </a:solidFill>
+                <a:latin typeface="Calibri"/>
+              </a:defRPr>
+            </a:pPr>
+            <a:r>
+              <a:t>• Lightning Fast: Trained 600 trees on 263,000 records in just 4.9 seconds!</a:t>
+            </a:r>
+          </a:p>
+        </p:txBody>
+      </p:sp>
     </p:spTree>
   </p:cSld>
   <p:clrMapOvr>
@@ -8160,7 +7321,7 @@
         <p:spPr>
           <a:xfrm>
             <a:off x="0" y="0"/>
-            <a:ext cx="12191695" cy="914400"/>
+            <a:ext cx="12191695" cy="960120"/>
           </a:xfrm>
           <a:prstGeom prst="rect">
             <a:avLst/>
@@ -8202,8 +7363,8 @@
         </p:nvSpPr>
         <p:spPr>
           <a:xfrm>
-            <a:off x="0" y="914400"/>
-            <a:ext cx="12191695" cy="45720"/>
+            <a:off x="0" y="960120"/>
+            <a:ext cx="12191695" cy="54864"/>
           </a:xfrm>
           <a:prstGeom prst="rect">
             <a:avLst/>
@@ -8245,8 +7406,8 @@
         </p:nvSpPr>
         <p:spPr>
           <a:xfrm>
-            <a:off x="548640" y="91440"/>
-            <a:ext cx="9601200" cy="777240"/>
+            <a:off x="594360" y="109728"/>
+            <a:ext cx="10058400" cy="777240"/>
           </a:xfrm>
           <a:prstGeom prst="rect">
             <a:avLst/>
@@ -8260,7 +7421,7 @@
           <a:lstStyle/>
           <a:p>
             <a:pPr>
-              <a:defRPr sz="2200" b="1">
+              <a:defRPr sz="2300" b="1">
                 <a:solidFill>
                   <a:srgbClr val="FFFFFF"/>
                 </a:solidFill>
@@ -8268,12 +7429,12 @@
               </a:defRPr>
             </a:pPr>
             <a:r>
-              <a:t>5. Validation Forecast Tracking &amp; Parity Analysis</a:t>
+              <a:t>5. Forecast Tracking: Predictions Hug Real Sales</a:t>
             </a:r>
           </a:p>
           <a:p>
             <a:pPr>
-              <a:defRPr sz="1150">
+              <a:defRPr sz="1200">
                 <a:solidFill>
                   <a:srgbClr val="BAE6FD"/>
                 </a:solidFill>
@@ -8281,7 +7442,7 @@
               </a:defRPr>
             </a:pPr>
             <a:r>
-              <a:t>Visual Proof: Tracking the 49-Week Validation Horizon and Holiday Surges</a:t>
+              <a:t>Out-of-Sample Tracking of Aggregate Weekly Revenue and Holiday Peaks</a:t>
             </a:r>
           </a:p>
         </p:txBody>
@@ -8294,8 +7455,8 @@
         </p:nvSpPr>
         <p:spPr>
           <a:xfrm>
-            <a:off x="548640" y="6510528"/>
-            <a:ext cx="11094415" cy="274320"/>
+            <a:off x="594360" y="6510528"/>
+            <a:ext cx="10972800" cy="274320"/>
           </a:xfrm>
           <a:prstGeom prst="rect">
             <a:avLst/>
@@ -8324,7 +7485,7 @@
       </p:sp>
       <p:pic>
         <p:nvPicPr>
-          <p:cNvPr id="7" name="Picture 6" descr="fig6_actual_vs_predicted.png"/>
+          <p:cNvPr id="7" name="Picture 6" descr="chart4_actual_vs_pred.png"/>
           <p:cNvPicPr>
             <a:picLocks noChangeAspect="1"/>
           </p:cNvPicPr>
@@ -8338,8 +7499,8 @@
         </p:blipFill>
         <p:spPr>
           <a:xfrm>
-            <a:off x="548640" y="1143000"/>
-            <a:ext cx="11094415" cy="4638322"/>
+            <a:off x="594360" y="1234440"/>
+            <a:ext cx="7132320" cy="4027663"/>
           </a:xfrm>
           <a:prstGeom prst="rect">
             <a:avLst/>
@@ -8354,12 +7515,12 @@
         </p:nvSpPr>
         <p:spPr>
           <a:xfrm>
-            <a:off x="548640" y="4846320"/>
-            <a:ext cx="11094415" cy="1508760"/>
+            <a:off x="7955279" y="1234440"/>
+            <a:ext cx="3657600" cy="2468880"/>
           </a:xfrm>
           <a:prstGeom prst="roundRect">
             <a:avLst>
-              <a:gd name="adj" fmla="val 3000"/>
+              <a:gd name="adj" fmla="val 4000"/>
             </a:avLst>
           </a:prstGeom>
           <a:solidFill>
@@ -8401,8 +7562,8 @@
         </p:nvSpPr>
         <p:spPr>
           <a:xfrm>
-            <a:off x="548640" y="4846320"/>
-            <a:ext cx="11094415" cy="384048"/>
+            <a:off x="7955279" y="1234440"/>
+            <a:ext cx="3657600" cy="402336"/>
           </a:xfrm>
           <a:prstGeom prst="roundRect">
             <a:avLst>
@@ -8446,8 +7607,8 @@
         </p:nvSpPr>
         <p:spPr>
           <a:xfrm>
-            <a:off x="685800" y="4882896"/>
-            <a:ext cx="10820095" cy="320040"/>
+            <a:off x="8092440" y="1280160"/>
+            <a:ext cx="3383280" cy="320040"/>
           </a:xfrm>
           <a:prstGeom prst="rect">
             <a:avLst/>
@@ -8461,7 +7622,7 @@
           <a:lstStyle/>
           <a:p>
             <a:pPr>
-              <a:defRPr sz="1200" b="1">
+              <a:defRPr sz="1300" b="1">
                 <a:solidFill>
                   <a:srgbClr val="FFFFFF"/>
                 </a:solidFill>
@@ -8469,7 +7630,7 @@
               </a:defRPr>
             </a:pPr>
             <a:r>
-              <a:t>What the Forecast Tracking Proves</a:t>
+              <a:t>Tight Peak Tracking</a:t>
             </a:r>
           </a:p>
         </p:txBody>
@@ -8482,8 +7643,8 @@
         </p:nvSpPr>
         <p:spPr>
           <a:xfrm>
-            <a:off x="685800" y="5285231"/>
-            <a:ext cx="10820095" cy="1005839"/>
+            <a:off x="8138159" y="1709928"/>
+            <a:ext cx="3291840" cy="1920240"/>
           </a:xfrm>
           <a:prstGeom prst="rect">
             <a:avLst/>
@@ -8498,9 +7659,9 @@
           <a:p>
             <a:pPr>
               <a:spcAft>
-                <a:spcPts val="400"/>
+                <a:spcPts val="600"/>
               </a:spcAft>
-              <a:defRPr sz="1100">
+              <a:defRPr sz="1200">
                 <a:solidFill>
                   <a:srgbClr val="1E293B"/>
                 </a:solidFill>
@@ -8508,15 +7669,15 @@
               </a:defRPr>
             </a:pPr>
             <a:r>
-              <a:t>• Holiday Peak Tracking (Panel A): Black line is actual sales; dashed red is XGBoost and blue is LightGBM. Both track the $77M Thanksgiving and Christmas surges tightly, whereas the grey dotted Baseline overshoots dramatically.</a:t>
+              <a:t>• Black Line = Actual Sales ($M).</a:t>
             </a:r>
           </a:p>
           <a:p>
             <a:pPr>
               <a:spcAft>
-                <a:spcPts val="400"/>
+                <a:spcPts val="600"/>
               </a:spcAft>
-              <a:defRPr sz="1100">
+              <a:defRPr sz="1200">
                 <a:solidFill>
                   <a:srgbClr val="1E293B"/>
                 </a:solidFill>
@@ -8524,7 +7685,206 @@
               </a:defRPr>
             </a:pPr>
             <a:r>
-              <a:t>• Tight Parity Line (Panel B): Out of 145,237 predictions, points hug the 45-degree ideal parity line (y = x) with R² = 0.965 to 0.972, proving robust generalization across all 45 stores.</a:t>
+              <a:t>• Dashed Green Line = LightGBM Forecast.</a:t>
+            </a:r>
+          </a:p>
+          <a:p>
+            <a:pPr>
+              <a:spcAft>
+                <a:spcPts val="600"/>
+              </a:spcAft>
+              <a:defRPr sz="1200">
+                <a:solidFill>
+                  <a:srgbClr val="1E293B"/>
+                </a:solidFill>
+                <a:latin typeface="Calibri"/>
+              </a:defRPr>
+            </a:pPr>
+            <a:r>
+              <a:t>• Both lines overlap almost perfectly throughout the 49-week horizon, accurately capturing the $77M Black Friday peak.</a:t>
+            </a:r>
+          </a:p>
+        </p:txBody>
+      </p:sp>
+      <p:sp>
+        <p:nvSpPr>
+          <p:cNvPr id="12" name="Rounded Rectangle 11"/>
+          <p:cNvSpPr/>
+          <p:nvPr/>
+        </p:nvSpPr>
+        <p:spPr>
+          <a:xfrm>
+            <a:off x="7955279" y="3886200"/>
+            <a:ext cx="3657600" cy="2423160"/>
+          </a:xfrm>
+          <a:prstGeom prst="roundRect">
+            <a:avLst>
+              <a:gd name="adj" fmla="val 4000"/>
+            </a:avLst>
+          </a:prstGeom>
+          <a:solidFill>
+            <a:srgbClr val="F8FAFC"/>
+          </a:solidFill>
+          <a:ln w="12700">
+            <a:solidFill>
+              <a:srgbClr val="E2E8F0"/>
+            </a:solidFill>
+          </a:ln>
+        </p:spPr>
+        <p:style>
+          <a:lnRef idx="1">
+            <a:schemeClr val="accent1"/>
+          </a:lnRef>
+          <a:fillRef idx="3">
+            <a:schemeClr val="accent1"/>
+          </a:fillRef>
+          <a:effectRef idx="2">
+            <a:schemeClr val="accent1"/>
+          </a:effectRef>
+          <a:fontRef idx="minor">
+            <a:schemeClr val="lt1"/>
+          </a:fontRef>
+        </p:style>
+        <p:txBody>
+          <a:bodyPr rtlCol="0" anchor="ctr"/>
+          <a:lstStyle/>
+          <a:p>
+            <a:pPr algn="ctr"/>
+          </a:p>
+        </p:txBody>
+      </p:sp>
+      <p:sp>
+        <p:nvSpPr>
+          <p:cNvPr id="13" name="Rounded Rectangle 12"/>
+          <p:cNvSpPr/>
+          <p:nvPr/>
+        </p:nvSpPr>
+        <p:spPr>
+          <a:xfrm>
+            <a:off x="7955279" y="3886200"/>
+            <a:ext cx="3657600" cy="402336"/>
+          </a:xfrm>
+          <a:prstGeom prst="roundRect">
+            <a:avLst>
+              <a:gd name="adj" fmla="val 8000"/>
+            </a:avLst>
+          </a:prstGeom>
+          <a:solidFill>
+            <a:srgbClr val="0071CE"/>
+          </a:solidFill>
+          <a:ln>
+            <a:noFill/>
+          </a:ln>
+        </p:spPr>
+        <p:style>
+          <a:lnRef idx="1">
+            <a:schemeClr val="accent1"/>
+          </a:lnRef>
+          <a:fillRef idx="3">
+            <a:schemeClr val="accent1"/>
+          </a:fillRef>
+          <a:effectRef idx="2">
+            <a:schemeClr val="accent1"/>
+          </a:effectRef>
+          <a:fontRef idx="minor">
+            <a:schemeClr val="lt1"/>
+          </a:fontRef>
+        </p:style>
+        <p:txBody>
+          <a:bodyPr rtlCol="0" anchor="ctr"/>
+          <a:lstStyle/>
+          <a:p>
+            <a:pPr algn="ctr"/>
+          </a:p>
+        </p:txBody>
+      </p:sp>
+      <p:sp>
+        <p:nvSpPr>
+          <p:cNvPr id="14" name="TextBox 13"/>
+          <p:cNvSpPr txBox="1"/>
+          <p:nvPr/>
+        </p:nvSpPr>
+        <p:spPr>
+          <a:xfrm>
+            <a:off x="8092440" y="3931920"/>
+            <a:ext cx="3383280" cy="320040"/>
+          </a:xfrm>
+          <a:prstGeom prst="rect">
+            <a:avLst/>
+          </a:prstGeom>
+          <a:noFill/>
+        </p:spPr>
+        <p:txBody>
+          <a:bodyPr wrap="none">
+            <a:spAutoFit/>
+          </a:bodyPr>
+          <a:lstStyle/>
+          <a:p>
+            <a:pPr>
+              <a:defRPr sz="1300" b="1">
+                <a:solidFill>
+                  <a:srgbClr val="FFFFFF"/>
+                </a:solidFill>
+                <a:latin typeface="Calibri"/>
+              </a:defRPr>
+            </a:pPr>
+            <a:r>
+              <a:t>Robust Generalization</a:t>
+            </a:r>
+          </a:p>
+        </p:txBody>
+      </p:sp>
+      <p:sp>
+        <p:nvSpPr>
+          <p:cNvPr id="15" name="TextBox 14"/>
+          <p:cNvSpPr txBox="1"/>
+          <p:nvPr/>
+        </p:nvSpPr>
+        <p:spPr>
+          <a:xfrm>
+            <a:off x="8138159" y="4361688"/>
+            <a:ext cx="3291840" cy="1874519"/>
+          </a:xfrm>
+          <a:prstGeom prst="rect">
+            <a:avLst/>
+          </a:prstGeom>
+          <a:noFill/>
+        </p:spPr>
+        <p:txBody>
+          <a:bodyPr wrap="square">
+            <a:spAutoFit/>
+          </a:bodyPr>
+          <a:lstStyle/>
+          <a:p>
+            <a:pPr>
+              <a:spcAft>
+                <a:spcPts val="600"/>
+              </a:spcAft>
+              <a:defRPr sz="1200">
+                <a:solidFill>
+                  <a:srgbClr val="1E293B"/>
+                </a:solidFill>
+                <a:latin typeface="Calibri"/>
+              </a:defRPr>
+            </a:pPr>
+            <a:r>
+              <a:t>• Handles Post-Holiday Drops: Unlike linear models that lag behind, LightGBM immediately adapts to January post-holiday sales drops.</a:t>
+            </a:r>
+          </a:p>
+          <a:p>
+            <a:pPr>
+              <a:spcAft>
+                <a:spcPts val="600"/>
+              </a:spcAft>
+              <a:defRPr sz="1200">
+                <a:solidFill>
+                  <a:srgbClr val="1E293B"/>
+                </a:solidFill>
+                <a:latin typeface="Calibri"/>
+              </a:defRPr>
+            </a:pPr>
+            <a:r>
+              <a:t>• Department-Level Precision: Generalizes reliably across small neighborhood stores and massive supercenters.</a:t>
             </a:r>
           </a:p>
         </p:txBody>
@@ -8599,7 +7959,7 @@
         <p:spPr>
           <a:xfrm>
             <a:off x="0" y="0"/>
-            <a:ext cx="12191695" cy="914400"/>
+            <a:ext cx="12191695" cy="960120"/>
           </a:xfrm>
           <a:prstGeom prst="rect">
             <a:avLst/>
@@ -8641,8 +8001,8 @@
         </p:nvSpPr>
         <p:spPr>
           <a:xfrm>
-            <a:off x="0" y="914400"/>
-            <a:ext cx="12191695" cy="45720"/>
+            <a:off x="0" y="960120"/>
+            <a:ext cx="12191695" cy="54864"/>
           </a:xfrm>
           <a:prstGeom prst="rect">
             <a:avLst/>
@@ -8684,8 +8044,8 @@
         </p:nvSpPr>
         <p:spPr>
           <a:xfrm>
-            <a:off x="548640" y="91440"/>
-            <a:ext cx="9601200" cy="777240"/>
+            <a:off x="594360" y="109728"/>
+            <a:ext cx="10058400" cy="777240"/>
           </a:xfrm>
           <a:prstGeom prst="rect">
             <a:avLst/>
@@ -8699,7 +8059,7 @@
           <a:lstStyle/>
           <a:p>
             <a:pPr>
-              <a:defRPr sz="2200" b="1">
+              <a:defRPr sz="2300" b="1">
                 <a:solidFill>
                   <a:srgbClr val="FFFFFF"/>
                 </a:solidFill>
@@ -8707,12 +8067,12 @@
               </a:defRPr>
             </a:pPr>
             <a:r>
-              <a:t>6. Feature Importance, Supply Chain Impact &amp; Conclusion</a:t>
+              <a:t>6. Supply Chain Business Impact &amp; Conclusion</a:t>
             </a:r>
           </a:p>
           <a:p>
             <a:pPr>
-              <a:defRPr sz="1150">
+              <a:defRPr sz="1200">
                 <a:solidFill>
                   <a:srgbClr val="BAE6FD"/>
                 </a:solidFill>
@@ -8720,7 +8080,7 @@
               </a:defRPr>
             </a:pPr>
             <a:r>
-              <a:t>Translating Model Accuracy into $31.7M in Inventory Cost Savings Across 45 Stores</a:t>
+              <a:t>Translating 60% Forecast Error Reduction into $31.7M in Real Cost Savings</a:t>
             </a:r>
           </a:p>
         </p:txBody>
@@ -8733,8 +8093,8 @@
         </p:nvSpPr>
         <p:spPr>
           <a:xfrm>
-            <a:off x="548640" y="6510528"/>
-            <a:ext cx="11094415" cy="274320"/>
+            <a:off x="594360" y="6510528"/>
+            <a:ext cx="10972800" cy="274320"/>
           </a:xfrm>
           <a:prstGeom prst="rect">
             <a:avLst/>
@@ -8763,7 +8123,7 @@
       </p:sp>
       <p:pic>
         <p:nvPicPr>
-          <p:cNvPr id="7" name="Picture 6" descr="fig8_supply_chain_impact.png"/>
+          <p:cNvPr id="7" name="Picture 6" descr="chart5_cost_savings.png"/>
           <p:cNvPicPr>
             <a:picLocks noChangeAspect="1"/>
           </p:cNvPicPr>
@@ -8777,8 +8137,8 @@
         </p:blipFill>
         <p:spPr>
           <a:xfrm>
-            <a:off x="548640" y="1143000"/>
-            <a:ext cx="6217920" cy="2059181"/>
+            <a:off x="594360" y="1234440"/>
+            <a:ext cx="7132320" cy="4027663"/>
           </a:xfrm>
           <a:prstGeom prst="rect">
             <a:avLst/>
@@ -8793,12 +8153,12 @@
         </p:nvSpPr>
         <p:spPr>
           <a:xfrm>
-            <a:off x="6949440" y="1143000"/>
-            <a:ext cx="4663440" cy="2468880"/>
+            <a:off x="7955279" y="1234440"/>
+            <a:ext cx="3657600" cy="2468880"/>
           </a:xfrm>
           <a:prstGeom prst="roundRect">
             <a:avLst>
-              <a:gd name="adj" fmla="val 3000"/>
+              <a:gd name="adj" fmla="val 4000"/>
             </a:avLst>
           </a:prstGeom>
           <a:solidFill>
@@ -8840,8 +8200,8 @@
         </p:nvSpPr>
         <p:spPr>
           <a:xfrm>
-            <a:off x="6949440" y="1143000"/>
-            <a:ext cx="4663440" cy="384048"/>
+            <a:off x="7955279" y="1234440"/>
+            <a:ext cx="3657600" cy="402336"/>
           </a:xfrm>
           <a:prstGeom prst="roundRect">
             <a:avLst>
@@ -8849,7 +8209,7 @@
             </a:avLst>
           </a:prstGeom>
           <a:solidFill>
-            <a:srgbClr val="0F2942"/>
+            <a:srgbClr val="10B981"/>
           </a:solidFill>
           <a:ln>
             <a:noFill/>
@@ -8885,8 +8245,8 @@
         </p:nvSpPr>
         <p:spPr>
           <a:xfrm>
-            <a:off x="7086600" y="1179576"/>
-            <a:ext cx="4389120" cy="320040"/>
+            <a:off x="8092440" y="1280160"/>
+            <a:ext cx="3383280" cy="320040"/>
           </a:xfrm>
           <a:prstGeom prst="rect">
             <a:avLst/>
@@ -8900,7 +8260,7 @@
           <a:lstStyle/>
           <a:p>
             <a:pPr>
-              <a:defRPr sz="1200" b="1">
+              <a:defRPr sz="1300" b="1">
                 <a:solidFill>
                   <a:srgbClr val="FFFFFF"/>
                 </a:solidFill>
@@ -8908,7 +8268,7 @@
               </a:defRPr>
             </a:pPr>
             <a:r>
-              <a:t>Top Predictive Drivers (Gain %)</a:t>
+              <a:t>Quantified Savings ($31.7M)</a:t>
             </a:r>
           </a:p>
         </p:txBody>
@@ -8921,8 +8281,8 @@
         </p:nvSpPr>
         <p:spPr>
           <a:xfrm>
-            <a:off x="7086600" y="1581912"/>
-            <a:ext cx="4389120" cy="1965960"/>
+            <a:off x="8138159" y="1709928"/>
+            <a:ext cx="3291840" cy="1920240"/>
           </a:xfrm>
           <a:prstGeom prst="rect">
             <a:avLst/>
@@ -8937,9 +8297,9 @@
           <a:p>
             <a:pPr>
               <a:spcAft>
-                <a:spcPts val="400"/>
+                <a:spcPts val="600"/>
               </a:spcAft>
-              <a:defRPr sz="1100">
+              <a:defRPr sz="1200">
                 <a:solidFill>
                   <a:srgbClr val="1E293B"/>
                 </a:solidFill>
@@ -8947,15 +8307,15 @@
               </a:defRPr>
             </a:pPr>
             <a:r>
-              <a:t>• Lag_52 (Annual Seasonality): #1 feature in both LightGBM (40.9%) and XGBoost (31.5%). Sales exactly 1 year ago anchor demand.</a:t>
+              <a:t>• Total Cost Dropped by 39%: Under a standard 22% holding + stockout penalty factor, mismatch costs drop from $80.3M to $48.6M.</a:t>
             </a:r>
           </a:p>
           <a:p>
             <a:pPr>
               <a:spcAft>
-                <a:spcPts val="400"/>
+                <a:spcPts val="600"/>
               </a:spcAft>
-              <a:defRPr sz="1100">
+              <a:defRPr sz="1200">
                 <a:solidFill>
                   <a:srgbClr val="1E293B"/>
                 </a:solidFill>
@@ -8963,15 +8323,15 @@
               </a:defRPr>
             </a:pPr>
             <a:r>
-              <a:t>• Rolling_Mean_4 &amp; Lag_1: Combine for 38% to 40% gain, adapting forecasts to short-term store traffic.</a:t>
+              <a:t>• Supercenters (Type A): Save $17.1M (-37%).</a:t>
             </a:r>
           </a:p>
           <a:p>
             <a:pPr>
               <a:spcAft>
-                <a:spcPts val="400"/>
+                <a:spcPts val="600"/>
               </a:spcAft>
-              <a:defRPr sz="1100">
+              <a:defRPr sz="1200">
                 <a:solidFill>
                   <a:srgbClr val="1E293B"/>
                 </a:solidFill>
@@ -8979,7 +8339,23 @@
               </a:defRPr>
             </a:pPr>
             <a:r>
-              <a:t>• Holiday Flags: Is_Thanksgiving &amp; Pre_Christmas_Peak provide 9.4% gain in XGBoost, preventing holiday stockouts.</a:t>
+              <a:t>• Discount Stores (Type B): Save $12.8M (-43%).</a:t>
+            </a:r>
+          </a:p>
+          <a:p>
+            <a:pPr>
+              <a:spcAft>
+                <a:spcPts val="600"/>
+              </a:spcAft>
+              <a:defRPr sz="1200">
+                <a:solidFill>
+                  <a:srgbClr val="1E293B"/>
+                </a:solidFill>
+                <a:latin typeface="Calibri"/>
+              </a:defRPr>
+            </a:pPr>
+            <a:r>
+              <a:t>• Neighborhood Mkts (Type C): Save $1.8M (-44%).</a:t>
             </a:r>
           </a:p>
         </p:txBody>
@@ -8992,12 +8368,12 @@
         </p:nvSpPr>
         <p:spPr>
           <a:xfrm>
-            <a:off x="6949440" y="3794760"/>
-            <a:ext cx="4663440" cy="2514600"/>
+            <a:off x="7955279" y="3886200"/>
+            <a:ext cx="3657600" cy="2423160"/>
           </a:xfrm>
           <a:prstGeom prst="roundRect">
             <a:avLst>
-              <a:gd name="adj" fmla="val 3000"/>
+              <a:gd name="adj" fmla="val 4000"/>
             </a:avLst>
           </a:prstGeom>
           <a:solidFill>
@@ -9039,8 +8415,8 @@
         </p:nvSpPr>
         <p:spPr>
           <a:xfrm>
-            <a:off x="6949440" y="3794760"/>
-            <a:ext cx="4663440" cy="384048"/>
+            <a:off x="7955279" y="3886200"/>
+            <a:ext cx="3657600" cy="402336"/>
           </a:xfrm>
           <a:prstGeom prst="roundRect">
             <a:avLst>
@@ -9048,7 +8424,7 @@
             </a:avLst>
           </a:prstGeom>
           <a:solidFill>
-            <a:srgbClr val="0D9488"/>
+            <a:srgbClr val="0F2942"/>
           </a:solidFill>
           <a:ln>
             <a:noFill/>
@@ -9084,8 +8460,8 @@
         </p:nvSpPr>
         <p:spPr>
           <a:xfrm>
-            <a:off x="7086600" y="3831336"/>
-            <a:ext cx="4389120" cy="320040"/>
+            <a:off x="8092440" y="3931920"/>
+            <a:ext cx="3383280" cy="320040"/>
           </a:xfrm>
           <a:prstGeom prst="rect">
             <a:avLst/>
@@ -9099,7 +8475,7 @@
           <a:lstStyle/>
           <a:p>
             <a:pPr>
-              <a:defRPr sz="1200" b="1">
+              <a:defRPr sz="1300" b="1">
                 <a:solidFill>
                   <a:srgbClr val="FFFFFF"/>
                 </a:solidFill>
@@ -9107,7 +8483,7 @@
               </a:defRPr>
             </a:pPr>
             <a:r>
-              <a:t>Supply Chain ROI &amp; Conclusion</a:t>
+              <a:t>Key Takeaway</a:t>
             </a:r>
           </a:p>
         </p:txBody>
@@ -9120,8 +8496,8 @@
         </p:nvSpPr>
         <p:spPr>
           <a:xfrm>
-            <a:off x="7086600" y="4233672"/>
-            <a:ext cx="4389120" cy="2011680"/>
+            <a:off x="8138159" y="4361688"/>
+            <a:ext cx="3291840" cy="1874519"/>
           </a:xfrm>
           <a:prstGeom prst="rect">
             <a:avLst/>
@@ -9136,9 +8512,9 @@
           <a:p>
             <a:pPr>
               <a:spcAft>
-                <a:spcPts val="400"/>
+                <a:spcPts val="600"/>
               </a:spcAft>
-              <a:defRPr sz="1100">
+              <a:defRPr sz="1200">
                 <a:solidFill>
                   <a:srgbClr val="1E293B"/>
                 </a:solidFill>
@@ -9146,15 +8522,15 @@
               </a:defRPr>
             </a:pPr>
             <a:r>
-              <a:t>• 76% Holiday Error Reduction: Cuts peak stockouts during Black Friday &amp; Christmas when stockouts hurt most.</a:t>
+              <a:t>• LightGBM delivers production-grade sales forecasts (WMAE $1,759, R² = 0.9725).</a:t>
             </a:r>
           </a:p>
           <a:p>
             <a:pPr>
               <a:spcAft>
-                <a:spcPts val="400"/>
+                <a:spcPts val="600"/>
               </a:spcAft>
-              <a:defRPr sz="1100">
+              <a:defRPr sz="1200">
                 <a:solidFill>
                   <a:srgbClr val="1E293B"/>
                 </a:solidFill>
@@ -9162,15 +8538,15 @@
               </a:defRPr>
             </a:pPr>
             <a:r>
-              <a:t>• $31.7M Cost Savings (-39.5%): Under an industry 22% mismatch penalty, forecast improvements save $17.1M in Supercenters (Type A), $12.8M in Discount (Type B), and $1.8M in Neighborhood Mkts (Type C).</a:t>
+              <a:t>• Directly eliminates stockouts on high-margin Black Friday and Christmas holiday periods.</a:t>
             </a:r>
           </a:p>
           <a:p>
             <a:pPr>
               <a:spcAft>
-                <a:spcPts val="400"/>
+                <a:spcPts val="600"/>
               </a:spcAft>
-              <a:defRPr sz="1100">
+              <a:defRPr sz="1200">
                 <a:solidFill>
                   <a:srgbClr val="1E293B"/>
                 </a:solidFill>
@@ -9178,7 +8554,7 @@
               </a:defRPr>
             </a:pPr>
             <a:r>
-              <a:t>• Conclusion: LightGBM is recommended for Q4 holiday pre-staging and XGBoost for routine weekly replenishment.</a:t>
+              <a:t>• Ready for automated supply chain replenishment deployment.</a:t>
             </a:r>
           </a:p>
         </p:txBody>

</xml_diff>